<commit_message>
Add a JavaFX + SQLite + Maven worked example to Module 18
Student Records: a JavaFX window (table, form, live search, chart) onto
an SQLite database, with a model, a repository holding all the SQL, and
a view with no SQL. 11 JUnit tests against an in-memory database. The
README covers the pom, module-info, the SDK route and common errors.
Linked from Modules 14b and 18 and the Module 18 project; slides and
Student Manual rebuilt.

Co-Authored-By: Claude Opus 5.5 <noreply@anthropic.com>
</commit_message>
<xml_diff>
--- a/Slides/Module-18-GUIs-with-JavaFX.pptx
+++ b/Slides/Module-18-GUIs-with-JavaFX.pptx
@@ -16,9 +16,10 @@
     <p:sldId id="264" r:id="rId10"/>
     <p:sldId id="265" r:id="rId11"/>
     <p:sldId id="266" r:id="rId12"/>
+    <p:sldId id="267" r:id="rId13"/>
   </p:sldIdLst>
   <p:notesMasterIdLst>
-    <p:notesMasterId r:id="rId13"/>
+    <p:notesMasterId r:id="rId14"/>
   </p:notesMasterIdLst>
   <p:sldSz cx="12192000" cy="6858000"/>
   <p:notesSz cx="6858000" cy="12192000"/>
@@ -117,7 +118,7 @@
   <p:extLst>
     <p:ext uri="{521415D9-36F7-43E2-AB2F-B90AF26B5E84}">
       <p14:sectionLst xmlns:p14="http://schemas.microsoft.com/office/powerpoint/2010/main">
-        <p14:section name="Module 18" id="{22f01a91-053e-c869-0215-c17cb6f5d71a}">
+        <p14:section name="Module 18" id="{ef73034b-6109-8f87-f4eb-1c9d46a457ff}">
           <p14:sldIdLst>
             <p14:sldId id="256"/>
             <p14:sldId id="257"/>
@@ -130,6 +131,7 @@
             <p14:sldId id="264"/>
             <p14:sldId id="265"/>
             <p14:sldId id="266"/>
+            <p14:sldId id="267"/>
           </p14:sldIdLst>
         </p14:section>
       </p14:sectionLst>
@@ -624,7 +626,7 @@
           <a:p>
             <a:r>
               <a:rPr lang="en-US" dirty="0"/>
-              <a:t/>
+              <a:t>The shape of the BEE 429 midsem: JavaFX + SQLite/JDBC + Maven. Demo: add a student, search 'mensah', close, reopen: the data is still there. The README covers the SDK route and the error messages.</a:t>
             </a:r>
             <a:endParaRPr lang="en-US" dirty="0"/>
           </a:p>
@@ -712,7 +714,7 @@
           <a:p>
             <a:r>
               <a:rPr lang="en-US" dirty="0"/>
-              <a:t>Sketch the window on paper first: each box is a pane. Stretch: SQLite storage (Module 14b).</a:t>
+              <a:t/>
             </a:r>
             <a:endParaRPr lang="en-US" dirty="0"/>
           </a:p>
@@ -736,6 +738,94 @@
             <a:fld id="{F7021451-1387-4CA6-816F-3879F97B5CBC}" type="slidenum">
               <a:rPr lang="en-US"/>
               <a:t>11</a:t>
+            </a:fld>
+            <a:endParaRPr lang="en-US"/>
+          </a:p>
+        </p:txBody>
+      </p:sp>
+    </p:spTree>
+    <p:extLst>
+      <p:ext uri="{BB962C8B-B14F-4D97-AF65-F5344CB8AC3E}">
+        <p14:creationId xmlns:p14="http://schemas.microsoft.com/office/powerpoint/2010/main" val="1024086991"/>
+      </p:ext>
+    </p:extLst>
+  </p:cSld>
+  <p:clrMapOvr>
+    <a:masterClrMapping/>
+  </p:clrMapOvr>
+</p:notes>
+</file>
+
+<file path=ppt/notesSlides/notesSlide12.xml><?xml version="1.0" encoding="utf-8"?>
+<p:notes xmlns:a="http://schemas.openxmlformats.org/drawingml/2006/main" xmlns:r="http://schemas.openxmlformats.org/officeDocument/2006/relationships" xmlns:p="http://schemas.openxmlformats.org/presentationml/2006/main">
+  <p:cSld>
+    <p:spTree>
+      <p:nvGrpSpPr>
+        <p:cNvPr id="1" name=""/>
+        <p:cNvGrpSpPr/>
+        <p:nvPr/>
+      </p:nvGrpSpPr>
+      <p:grpSpPr>
+        <a:xfrm>
+          <a:off x="0" y="0"/>
+          <a:ext cx="0" cy="0"/>
+          <a:chOff x="0" y="0"/>
+          <a:chExt cx="0" cy="0"/>
+        </a:xfrm>
+      </p:grpSpPr>
+      <p:sp>
+        <p:nvSpPr>
+          <p:cNvPr id="2" name="Slide Image Placeholder 1"/>
+          <p:cNvSpPr>
+            <a:spLocks noGrp="1" noRot="1" noChangeAspect="1"/>
+          </p:cNvSpPr>
+          <p:nvPr>
+            <p:ph type="sldImg"/>
+          </p:nvPr>
+        </p:nvSpPr>
+        <p:spPr/>
+      </p:sp>
+      <p:sp>
+        <p:nvSpPr>
+          <p:cNvPr id="3" name="Notes Placeholder 2"/>
+          <p:cNvSpPr>
+            <a:spLocks noGrp="1"/>
+          </p:cNvSpPr>
+          <p:nvPr>
+            <p:ph type="body" idx="1"/>
+          </p:nvPr>
+        </p:nvSpPr>
+        <p:spPr/>
+        <p:txBody>
+          <a:bodyPr/>
+          <a:lstStyle/>
+          <a:p>
+            <a:r>
+              <a:rPr lang="en-US" dirty="0"/>
+              <a:t>Sketch the window on paper first: each box is a pane. Stretch: SQLite storage (Module 14b).</a:t>
+            </a:r>
+            <a:endParaRPr lang="en-US" dirty="0"/>
+          </a:p>
+        </p:txBody>
+      </p:sp>
+      <p:sp>
+        <p:nvSpPr>
+          <p:cNvPr id="4" name="Slide Number Placeholder 3"/>
+          <p:cNvSpPr>
+            <a:spLocks noGrp="1"/>
+          </p:cNvSpPr>
+          <p:nvPr>
+            <p:ph type="sldNum" sz="quarter" idx="10"/>
+          </p:nvPr>
+        </p:nvSpPr>
+        <p:spPr/>
+        <p:txBody>
+          <a:bodyPr/>
+          <a:lstStyle/>
+          <a:p>
+            <a:fld id="{F7021451-1387-4CA6-816F-3879F97B5CBC}" type="slidenum">
+              <a:rPr lang="en-US"/>
+              <a:t>12</a:t>
             </a:fld>
             <a:endParaRPr lang="en-US"/>
           </a:p>
@@ -2478,7 +2568,7 @@
         <p:spPr>
           <a:xfrm>
             <a:off x="548640" y="411480"/>
-            <a:ext cx="1193292" cy="310896"/>
+            <a:ext cx="1627632" cy="310896"/>
           </a:xfrm>
           <a:prstGeom prst="roundRect">
             <a:avLst>
@@ -2486,7 +2576,7 @@
             </a:avLst>
           </a:prstGeom>
           <a:solidFill>
-            <a:srgbClr val="F89820"/>
+            <a:srgbClr val="2F6F9F"/>
           </a:solidFill>
           <a:ln/>
         </p:spPr>
@@ -2500,7 +2590,7 @@
         <p:spPr>
           <a:xfrm>
             <a:off x="548640" y="411480"/>
-            <a:ext cx="1193292" cy="310896"/>
+            <a:ext cx="1627632" cy="310896"/>
           </a:xfrm>
           <a:prstGeom prst="rect">
             <a:avLst/>
@@ -2518,10 +2608,10 @@
             <a:r>
               <a:rPr lang="en-US" sz="1050" b="1" spc="150" kern="0" dirty="0">
                 <a:solidFill>
-                  <a:srgbClr val="152536"/>
-                </a:solidFill>
-              </a:rPr>
-              <a:t>WATCH OUT</a:t>
+                  <a:srgbClr val="FFFFFF"/>
+                </a:solidFill>
+              </a:rPr>
+              <a:t>WORKED EXAMPLE</a:t>
             </a:r>
             <a:endParaRPr lang="en-US" sz="1050" dirty="0"/>
           </a:p>
@@ -2556,13 +2646,13 @@
             <a:r>
               <a:rPr lang="en-US" sz="3200" b="1" dirty="0">
                 <a:solidFill>
-                  <a:srgbClr val="FFFFFF"/>
+                  <a:srgbClr val="14273E"/>
                 </a:solidFill>
                 <a:latin typeface="Cambria" pitchFamily="34" charset="0"/>
                 <a:ea typeface="Cambria" pitchFamily="34" charset="-122"/>
                 <a:cs typeface="Cambria" pitchFamily="34" charset="-120"/>
               </a:rPr>
-              <a:t>Common beginner mistakes</a:t>
+              <a:t>A window onto a database</a:t>
             </a:r>
             <a:endParaRPr lang="en-US" sz="3200" dirty="0"/>
           </a:p>
@@ -2570,24 +2660,31 @@
       </p:sp>
       <p:sp>
         <p:nvSpPr>
-          <p:cNvPr id="5" name="Mistake 1"/>
+          <p:cNvPr id="5" name="Code window"/>
           <p:cNvSpPr/>
           <p:nvPr/>
         </p:nvSpPr>
         <p:spPr>
           <a:xfrm>
-            <a:off x="548640" y="1828800"/>
-            <a:ext cx="5387188" cy="1310640"/>
+            <a:off x="548640" y="1783080"/>
+            <a:ext cx="6675120" cy="4343400"/>
           </a:xfrm>
           <a:prstGeom prst="roundRect">
             <a:avLst>
-              <a:gd name="adj" fmla="val 5581"/>
+              <a:gd name="adj" fmla="val 2526"/>
             </a:avLst>
           </a:prstGeom>
           <a:solidFill>
-            <a:srgbClr val="22384F"/>
+            <a:srgbClr val="17263A"/>
           </a:solidFill>
           <a:ln/>
+          <a:effectLst>
+            <a:outerShdw sx="100000" sy="100000" kx="0" ky="0" algn="bl" rotWithShape="0" blurRad="76200" dist="25400" dir="5400000">
+              <a:srgbClr val="000000">
+                <a:alpha val="18000"/>
+              </a:srgbClr>
+            </a:outerShdw>
+          </a:effectLst>
         </p:spPr>
       </p:sp>
       <p:sp>
@@ -2598,28 +2695,68 @@
         </p:nvSpPr>
         <p:spPr>
           <a:xfrm>
-            <a:off x="777240" y="2273808"/>
-            <a:ext cx="420624" cy="420624"/>
+            <a:off x="749808" y="1938528"/>
+            <a:ext cx="109728" cy="109728"/>
           </a:xfrm>
           <a:prstGeom prst="ellipse">
             <a:avLst/>
           </a:prstGeom>
           <a:solidFill>
-            <a:srgbClr val="F89820"/>
+            <a:srgbClr val="FF5F57"/>
           </a:solidFill>
           <a:ln/>
         </p:spPr>
       </p:sp>
       <p:sp>
         <p:nvSpPr>
-          <p:cNvPr id="7" name="Text 5"/>
+          <p:cNvPr id="7" name="Shape 5"/>
+          <p:cNvSpPr/>
+          <p:nvPr/>
+        </p:nvSpPr>
+        <p:spPr>
+          <a:xfrm>
+            <a:off x="950976" y="1938528"/>
+            <a:ext cx="109728" cy="109728"/>
+          </a:xfrm>
+          <a:prstGeom prst="ellipse">
+            <a:avLst/>
+          </a:prstGeom>
+          <a:solidFill>
+            <a:srgbClr val="FEBC2E"/>
+          </a:solidFill>
+          <a:ln/>
+        </p:spPr>
+      </p:sp>
+      <p:sp>
+        <p:nvSpPr>
+          <p:cNvPr id="8" name="Shape 6"/>
+          <p:cNvSpPr/>
+          <p:nvPr/>
+        </p:nvSpPr>
+        <p:spPr>
+          <a:xfrm>
+            <a:off x="1152144" y="1938528"/>
+            <a:ext cx="109728" cy="109728"/>
+          </a:xfrm>
+          <a:prstGeom prst="ellipse">
+            <a:avLst/>
+          </a:prstGeom>
+          <a:solidFill>
+            <a:srgbClr val="28C840"/>
+          </a:solidFill>
+          <a:ln/>
+        </p:spPr>
+      </p:sp>
+      <p:sp>
+        <p:nvSpPr>
+          <p:cNvPr id="9" name="Text 7"/>
           <p:cNvSpPr txBox="1"/>
           <p:nvPr/>
         </p:nvSpPr>
         <p:spPr>
           <a:xfrm>
-            <a:off x="777240" y="2273808"/>
-            <a:ext cx="420624" cy="420624"/>
+            <a:off x="1463040" y="1856232"/>
+            <a:ext cx="5577840" cy="274320"/>
           </a:xfrm>
           <a:prstGeom prst="rect">
             <a:avLst/>
@@ -2631,31 +2768,34 @@
           <a:bodyPr wrap="square" lIns="0" tIns="0" rIns="0" bIns="0" rtlCol="0" anchor="ctr"/>
           <a:lstStyle/>
           <a:p>
-            <a:pPr algn="ctr" indent="0" marL="0">
+            <a:pPr indent="0" marL="0">
               <a:buNone/>
             </a:pPr>
             <a:r>
-              <a:rPr lang="en-US" sz="1400" b="1" dirty="0">
-                <a:solidFill>
-                  <a:srgbClr val="152536"/>
-                </a:solidFill>
-              </a:rPr>
-              <a:t>!</a:t>
-            </a:r>
-            <a:endParaRPr lang="en-US" sz="1400" dirty="0"/>
+              <a:rPr lang="en-US" sz="1000" dirty="0">
+                <a:solidFill>
+                  <a:srgbClr val="8FA3BC"/>
+                </a:solidFill>
+                <a:latin typeface="Consolas" pitchFamily="34" charset="0"/>
+                <a:ea typeface="Consolas" pitchFamily="34" charset="-122"/>
+                <a:cs typeface="Consolas" pitchFamily="34" charset="-120"/>
+              </a:rPr>
+              <a:t>worked-example-student-records</a:t>
+            </a:r>
+            <a:endParaRPr lang="en-US" sz="1000" dirty="0"/>
           </a:p>
         </p:txBody>
       </p:sp>
       <p:sp>
         <p:nvSpPr>
-          <p:cNvPr id="8" name="Text 6"/>
+          <p:cNvPr id="10" name="Code"/>
           <p:cNvSpPr txBox="1"/>
           <p:nvPr/>
         </p:nvSpPr>
         <p:spPr>
           <a:xfrm>
-            <a:off x="1371600" y="1828800"/>
-            <a:ext cx="4381348" cy="1310640"/>
+            <a:off x="777240" y="2194560"/>
+            <a:ext cx="6309360" cy="3794760"/>
           </a:xfrm>
           <a:prstGeom prst="rect">
             <a:avLst/>
@@ -2664,76 +2804,202 @@
           <a:ln/>
         </p:spPr>
         <p:txBody>
-          <a:bodyPr wrap="square" lIns="0" tIns="0" rIns="0" bIns="0" rtlCol="0" anchor="ctr"/>
+          <a:bodyPr wrap="square" lIns="0" tIns="0" rIns="0" bIns="0" rtlCol="0" anchor="t"/>
           <a:lstStyle/>
           <a:p>
             <a:pPr indent="0" marL="0">
               <a:buNone/>
             </a:pPr>
             <a:r>
-              <a:rPr lang="en-US" sz="1450" dirty="0">
-                <a:solidFill>
-                  <a:srgbClr val="FFFFFF"/>
-                </a:solidFill>
-              </a:rPr>
-              <a:t>"JavaFX runtime components are missing".</a:t>
-            </a:r>
-            <a:endParaRPr lang="en-US" sz="1450" dirty="0"/>
+              <a:rPr lang="en-US" sz="1000" dirty="0">
+                <a:solidFill>
+                  <a:srgbClr val="E6EDF3"/>
+                </a:solidFill>
+                <a:latin typeface="Consolas" pitchFamily="34" charset="0"/>
+                <a:ea typeface="Consolas" pitchFamily="34" charset="-122"/>
+                <a:cs typeface="Consolas" pitchFamily="34" charset="-120"/>
+              </a:rPr>
+              <a:t>pom.xml              javafx-controls + sqlite-jdbc + junit-jupiter</a:t>
+            </a:r>
+            <a:endParaRPr lang="en-US" sz="1000" dirty="0"/>
+          </a:p>
+          <a:p>
+            <a:pPr indent="0" marL="0">
+              <a:buNone/>
+            </a:pPr>
+            <a:r>
+              <a:rPr lang="en-US" sz="1000" dirty="0">
+                <a:solidFill>
+                  <a:srgbClr val="E6EDF3"/>
+                </a:solidFill>
+                <a:latin typeface="Consolas" pitchFamily="34" charset="0"/>
+                <a:ea typeface="Consolas" pitchFamily="34" charset="-122"/>
+                <a:cs typeface="Consolas" pitchFamily="34" charset="-120"/>
+              </a:rPr>
+              <a:t>module-info.java     requires javafx.controls;</a:t>
+            </a:r>
+            <a:endParaRPr lang="en-US" sz="1000" dirty="0"/>
+          </a:p>
+          <a:p>
+            <a:pPr indent="0" marL="0">
+              <a:buNone/>
+            </a:pPr>
+            <a:r>
+              <a:rPr lang="en-US" sz="1000" dirty="0">
+                <a:solidFill>
+                  <a:srgbClr val="E6EDF3"/>
+                </a:solidFill>
+                <a:latin typeface="Consolas" pitchFamily="34" charset="0"/>
+                <a:ea typeface="Consolas" pitchFamily="34" charset="-122"/>
+                <a:cs typeface="Consolas" pitchFamily="34" charset="-120"/>
+              </a:rPr>
+              <a:t>                     requires java.sql;</a:t>
+            </a:r>
+            <a:endParaRPr lang="en-US" sz="1000" dirty="0"/>
+          </a:p>
+          <a:p>
+            <a:pPr indent="0" marL="0">
+              <a:buNone/>
+            </a:pPr>
+            <a:r>
+              <a:rPr lang="en-US" sz="1000" dirty="0">
+                <a:solidFill>
+                  <a:srgbClr val="E6EDF3"/>
+                </a:solidFill>
+                <a:latin typeface="Consolas" pitchFamily="34" charset="0"/>
+                <a:ea typeface="Consolas" pitchFamily="34" charset="-122"/>
+                <a:cs typeface="Consolas" pitchFamily="34" charset="-120"/>
+              </a:rPr>
+              <a:t>                     requires org.xerial.sqlitejdbc;</a:t>
+            </a:r>
+            <a:endParaRPr lang="en-US" sz="1000" dirty="0"/>
+          </a:p>
+          <a:p>
+            <a:pPr indent="0" marL="0">
+              <a:buNone/>
+            </a:pPr>
+            <a:endParaRPr lang="en-US" sz="1000" dirty="0"/>
+          </a:p>
+          <a:p>
+            <a:pPr indent="0" marL="0">
+              <a:buNone/>
+            </a:pPr>
+            <a:r>
+              <a:rPr lang="en-US" sz="1000" dirty="0">
+                <a:solidFill>
+                  <a:srgbClr val="E6EDF3"/>
+                </a:solidFill>
+                <a:latin typeface="Consolas" pitchFamily="34" charset="0"/>
+                <a:ea typeface="Consolas" pitchFamily="34" charset="-122"/>
+                <a:cs typeface="Consolas" pitchFamily="34" charset="-120"/>
+              </a:rPr>
+              <a:t>Student              the MODEL:   a record with its rules (no JavaFX, no SQL)</a:t>
+            </a:r>
+            <a:endParaRPr lang="en-US" sz="1000" dirty="0"/>
+          </a:p>
+          <a:p>
+            <a:pPr indent="0" marL="0">
+              <a:buNone/>
+            </a:pPr>
+            <a:r>
+              <a:rPr lang="en-US" sz="1000" dirty="0">
+                <a:solidFill>
+                  <a:srgbClr val="E6EDF3"/>
+                </a:solidFill>
+                <a:latin typeface="Consolas" pitchFamily="34" charset="0"/>
+                <a:ea typeface="Consolas" pitchFamily="34" charset="-122"/>
+                <a:cs typeface="Consolas" pitchFamily="34" charset="-120"/>
+              </a:rPr>
+              <a:t>StudentRepository    the STORAGE: ALL the SQL, PreparedStatements only</a:t>
+            </a:r>
+            <a:endParaRPr lang="en-US" sz="1000" dirty="0"/>
+          </a:p>
+          <a:p>
+            <a:pPr indent="0" marL="0">
+              <a:buNone/>
+            </a:pPr>
+            <a:r>
+              <a:rPr lang="en-US" sz="1000" dirty="0">
+                <a:solidFill>
+                  <a:srgbClr val="E6EDF3"/>
+                </a:solidFill>
+                <a:latin typeface="Consolas" pitchFamily="34" charset="0"/>
+                <a:ea typeface="Consolas" pitchFamily="34" charset="-122"/>
+                <a:cs typeface="Consolas" pitchFamily="34" charset="-120"/>
+              </a:rPr>
+              <a:t>RecordsApp           the VIEW:    table, form, search, chart (no SQL)</a:t>
+            </a:r>
+            <a:endParaRPr lang="en-US" sz="1000" dirty="0"/>
+          </a:p>
+          <a:p>
+            <a:pPr indent="0" marL="0">
+              <a:buNone/>
+            </a:pPr>
+            <a:r>
+              <a:rPr lang="en-US" sz="1000" dirty="0">
+                <a:solidFill>
+                  <a:srgbClr val="E6EDF3"/>
+                </a:solidFill>
+                <a:latin typeface="Consolas" pitchFamily="34" charset="0"/>
+                <a:ea typeface="Consolas" pitchFamily="34" charset="-122"/>
+                <a:cs typeface="Consolas" pitchFamily="34" charset="-120"/>
+              </a:rPr>
+              <a:t>  start()  opens students.db      stop()  closes it</a:t>
+            </a:r>
+            <a:endParaRPr lang="en-US" sz="1000" dirty="0"/>
+          </a:p>
+          <a:p>
+            <a:pPr indent="0" marL="0">
+              <a:buNone/>
+            </a:pPr>
+            <a:endParaRPr lang="en-US" sz="1000" dirty="0"/>
+          </a:p>
+          <a:p>
+            <a:pPr indent="0" marL="0">
+              <a:buNone/>
+            </a:pPr>
+            <a:r>
+              <a:rPr lang="en-US" sz="1000" dirty="0">
+                <a:solidFill>
+                  <a:srgbClr val="E6EDF3"/>
+                </a:solidFill>
+                <a:latin typeface="Consolas" pitchFamily="34" charset="0"/>
+                <a:ea typeface="Consolas" pitchFamily="34" charset="-122"/>
+                <a:cs typeface="Consolas" pitchFamily="34" charset="-120"/>
+              </a:rPr>
+              <a:t>$ ./mvnw javafx:run</a:t>
+            </a:r>
+            <a:endParaRPr lang="en-US" sz="1000" dirty="0"/>
+          </a:p>
+          <a:p>
+            <a:pPr indent="0" marL="0">
+              <a:buNone/>
+            </a:pPr>
+            <a:r>
+              <a:rPr lang="en-US" sz="1000" dirty="0">
+                <a:solidFill>
+                  <a:srgbClr val="E6EDF3"/>
+                </a:solidFill>
+                <a:latin typeface="Consolas" pitchFamily="34" charset="0"/>
+                <a:ea typeface="Consolas" pitchFamily="34" charset="-122"/>
+                <a:cs typeface="Consolas" pitchFamily="34" charset="-120"/>
+              </a:rPr>
+              <a:t>$ ./mvnw test                     11 tests, in-memory database, no window</a:t>
+            </a:r>
+            <a:endParaRPr lang="en-US" sz="1000" dirty="0"/>
           </a:p>
         </p:txBody>
       </p:sp>
       <p:sp>
         <p:nvSpPr>
-          <p:cNvPr id="9" name="Mistake 2"/>
-          <p:cNvSpPr/>
-          <p:nvPr/>
-        </p:nvSpPr>
-        <p:spPr>
-          <a:xfrm>
-            <a:off x="6255868" y="1828800"/>
-            <a:ext cx="5387188" cy="1310640"/>
-          </a:xfrm>
-          <a:prstGeom prst="roundRect">
-            <a:avLst>
-              <a:gd name="adj" fmla="val 5581"/>
-            </a:avLst>
-          </a:prstGeom>
-          <a:solidFill>
-            <a:srgbClr val="22384F"/>
-          </a:solidFill>
-          <a:ln/>
-        </p:spPr>
-      </p:sp>
-      <p:sp>
-        <p:nvSpPr>
-          <p:cNvPr id="10" name="Shape 8"/>
-          <p:cNvSpPr/>
-          <p:nvPr/>
-        </p:nvSpPr>
-        <p:spPr>
-          <a:xfrm>
-            <a:off x="6484468" y="2273808"/>
-            <a:ext cx="420624" cy="420624"/>
-          </a:xfrm>
-          <a:prstGeom prst="ellipse">
-            <a:avLst/>
-          </a:prstGeom>
-          <a:solidFill>
-            <a:srgbClr val="F89820"/>
-          </a:solidFill>
-          <a:ln/>
-        </p:spPr>
-      </p:sp>
-      <p:sp>
-        <p:nvSpPr>
-          <p:cNvPr id="11" name="Text 9"/>
+          <p:cNvPr id="11" name="Bullets"/>
           <p:cNvSpPr txBox="1"/>
           <p:nvPr/>
         </p:nvSpPr>
         <p:spPr>
           <a:xfrm>
-            <a:off x="6484468" y="2273808"/>
-            <a:ext cx="420624" cy="420624"/>
+            <a:off x="7589520" y="1828800"/>
+            <a:ext cx="4069080" cy="4251960"/>
           </a:xfrm>
           <a:prstGeom prst="rect">
             <a:avLst/>
@@ -2742,562 +3008,61 @@
           <a:ln/>
         </p:spPr>
         <p:txBody>
-          <a:bodyPr wrap="square" lIns="0" tIns="0" rIns="0" bIns="0" rtlCol="0" anchor="ctr"/>
+          <a:bodyPr wrap="square" lIns="0" tIns="0" rIns="0" bIns="0" rtlCol="0" anchor="t"/>
           <a:lstStyle/>
           <a:p>
-            <a:pPr algn="ctr" indent="0" marL="0">
-              <a:buNone/>
-            </a:pPr>
-            <a:r>
-              <a:rPr lang="en-US" sz="1400" b="1" dirty="0">
-                <a:solidFill>
-                  <a:srgbClr val="152536"/>
-                </a:solidFill>
-              </a:rPr>
-              <a:t>!</a:t>
-            </a:r>
-            <a:endParaRPr lang="en-US" sz="1400" dirty="0"/>
-          </a:p>
-        </p:txBody>
-      </p:sp>
-      <p:sp>
-        <p:nvSpPr>
-          <p:cNvPr id="12" name="Text 10"/>
-          <p:cNvSpPr txBox="1"/>
-          <p:nvPr/>
-        </p:nvSpPr>
-        <p:spPr>
-          <a:xfrm>
-            <a:off x="7078828" y="1828800"/>
-            <a:ext cx="4381348" cy="1310640"/>
-          </a:xfrm>
-          <a:prstGeom prst="rect">
-            <a:avLst/>
-          </a:prstGeom>
-          <a:noFill/>
-          <a:ln/>
-        </p:spPr>
-        <p:txBody>
-          <a:bodyPr wrap="square" lIns="0" tIns="0" rIns="0" bIns="0" rtlCol="0" anchor="ctr"/>
-          <a:lstStyle/>
-          <a:p>
-            <a:pPr indent="0" marL="0">
-              <a:buNone/>
-            </a:pPr>
-            <a:r>
-              <a:rPr lang="en-US" sz="1450" dirty="0">
-                <a:solidFill>
-                  <a:srgbClr val="FFFFFF"/>
-                </a:solidFill>
-              </a:rPr>
-              <a:t>Forgetting </a:t>
-            </a:r>
-            <a:r>
-              <a:rPr lang="en-US" sz="1450" dirty="0">
-                <a:solidFill>
-                  <a:srgbClr val="F89820"/>
-                </a:solidFill>
-                <a:latin typeface="Consolas" pitchFamily="34" charset="0"/>
-                <a:ea typeface="Consolas" pitchFamily="34" charset="-122"/>
-                <a:cs typeface="Consolas" pitchFamily="34" charset="-120"/>
-              </a:rPr>
-              <a:t>stage.show()</a:t>
-            </a:r>
-            <a:r>
-              <a:rPr lang="en-US" sz="1450" dirty="0">
-                <a:solidFill>
-                  <a:srgbClr val="FFFFFF"/>
-                </a:solidFill>
-              </a:rPr>
-              <a:t>.</a:t>
-            </a:r>
-            <a:endParaRPr lang="en-US" sz="1450" dirty="0"/>
-          </a:p>
-        </p:txBody>
-      </p:sp>
-      <p:sp>
-        <p:nvSpPr>
-          <p:cNvPr id="13" name="Mistake 3"/>
-          <p:cNvSpPr/>
-          <p:nvPr/>
-        </p:nvSpPr>
-        <p:spPr>
-          <a:xfrm>
-            <a:off x="548640" y="3368040"/>
-            <a:ext cx="5387188" cy="1310640"/>
-          </a:xfrm>
-          <a:prstGeom prst="roundRect">
-            <a:avLst>
-              <a:gd name="adj" fmla="val 5581"/>
-            </a:avLst>
-          </a:prstGeom>
-          <a:solidFill>
-            <a:srgbClr val="22384F"/>
-          </a:solidFill>
-          <a:ln/>
-        </p:spPr>
-      </p:sp>
-      <p:sp>
-        <p:nvSpPr>
-          <p:cNvPr id="14" name="Shape 12"/>
-          <p:cNvSpPr/>
-          <p:nvPr/>
-        </p:nvSpPr>
-        <p:spPr>
-          <a:xfrm>
-            <a:off x="777240" y="3813048"/>
-            <a:ext cx="420624" cy="420624"/>
-          </a:xfrm>
-          <a:prstGeom prst="ellipse">
-            <a:avLst/>
-          </a:prstGeom>
-          <a:solidFill>
-            <a:srgbClr val="F89820"/>
-          </a:solidFill>
-          <a:ln/>
-        </p:spPr>
-      </p:sp>
-      <p:sp>
-        <p:nvSpPr>
-          <p:cNvPr id="15" name="Text 13"/>
-          <p:cNvSpPr txBox="1"/>
-          <p:nvPr/>
-        </p:nvSpPr>
-        <p:spPr>
-          <a:xfrm>
-            <a:off x="777240" y="3813048"/>
-            <a:ext cx="420624" cy="420624"/>
-          </a:xfrm>
-          <a:prstGeom prst="rect">
-            <a:avLst/>
-          </a:prstGeom>
-          <a:noFill/>
-          <a:ln/>
-        </p:spPr>
-        <p:txBody>
-          <a:bodyPr wrap="square" lIns="0" tIns="0" rIns="0" bIns="0" rtlCol="0" anchor="ctr"/>
-          <a:lstStyle/>
-          <a:p>
-            <a:pPr algn="ctr" indent="0" marL="0">
-              <a:buNone/>
-            </a:pPr>
-            <a:r>
-              <a:rPr lang="en-US" sz="1400" b="1" dirty="0">
-                <a:solidFill>
-                  <a:srgbClr val="152536"/>
-                </a:solidFill>
-              </a:rPr>
-              <a:t>!</a:t>
-            </a:r>
-            <a:endParaRPr lang="en-US" sz="1400" dirty="0"/>
-          </a:p>
-        </p:txBody>
-      </p:sp>
-      <p:sp>
-        <p:nvSpPr>
-          <p:cNvPr id="16" name="Text 14"/>
-          <p:cNvSpPr txBox="1"/>
-          <p:nvPr/>
-        </p:nvSpPr>
-        <p:spPr>
-          <a:xfrm>
-            <a:off x="1371600" y="3368040"/>
-            <a:ext cx="4381348" cy="1310640"/>
-          </a:xfrm>
-          <a:prstGeom prst="rect">
-            <a:avLst/>
-          </a:prstGeom>
-          <a:noFill/>
-          <a:ln/>
-        </p:spPr>
-        <p:txBody>
-          <a:bodyPr wrap="square" lIns="0" tIns="0" rIns="0" bIns="0" rtlCol="0" anchor="ctr"/>
-          <a:lstStyle/>
-          <a:p>
-            <a:pPr indent="0" marL="0">
-              <a:buNone/>
-            </a:pPr>
-            <a:r>
-              <a:rPr lang="en-US" sz="1450" dirty="0">
-                <a:solidFill>
-                  <a:srgbClr val="FFFFFF"/>
-                </a:solidFill>
-              </a:rPr>
-              <a:t>A node never added to a pane, or added twice.</a:t>
-            </a:r>
-            <a:endParaRPr lang="en-US" sz="1450" dirty="0"/>
-          </a:p>
-        </p:txBody>
-      </p:sp>
-      <p:sp>
-        <p:nvSpPr>
-          <p:cNvPr id="17" name="Mistake 4"/>
-          <p:cNvSpPr/>
-          <p:nvPr/>
-        </p:nvSpPr>
-        <p:spPr>
-          <a:xfrm>
-            <a:off x="6255868" y="3368040"/>
-            <a:ext cx="5387188" cy="1310640"/>
-          </a:xfrm>
-          <a:prstGeom prst="roundRect">
-            <a:avLst>
-              <a:gd name="adj" fmla="val 5581"/>
-            </a:avLst>
-          </a:prstGeom>
-          <a:solidFill>
-            <a:srgbClr val="22384F"/>
-          </a:solidFill>
-          <a:ln/>
-        </p:spPr>
-      </p:sp>
-      <p:sp>
-        <p:nvSpPr>
-          <p:cNvPr id="18" name="Shape 16"/>
-          <p:cNvSpPr/>
-          <p:nvPr/>
-        </p:nvSpPr>
-        <p:spPr>
-          <a:xfrm>
-            <a:off x="6484468" y="3813048"/>
-            <a:ext cx="420624" cy="420624"/>
-          </a:xfrm>
-          <a:prstGeom prst="ellipse">
-            <a:avLst/>
-          </a:prstGeom>
-          <a:solidFill>
-            <a:srgbClr val="F89820"/>
-          </a:solidFill>
-          <a:ln/>
-        </p:spPr>
-      </p:sp>
-      <p:sp>
-        <p:nvSpPr>
-          <p:cNvPr id="19" name="Text 17"/>
-          <p:cNvSpPr txBox="1"/>
-          <p:nvPr/>
-        </p:nvSpPr>
-        <p:spPr>
-          <a:xfrm>
-            <a:off x="6484468" y="3813048"/>
-            <a:ext cx="420624" cy="420624"/>
-          </a:xfrm>
-          <a:prstGeom prst="rect">
-            <a:avLst/>
-          </a:prstGeom>
-          <a:noFill/>
-          <a:ln/>
-        </p:spPr>
-        <p:txBody>
-          <a:bodyPr wrap="square" lIns="0" tIns="0" rIns="0" bIns="0" rtlCol="0" anchor="ctr"/>
-          <a:lstStyle/>
-          <a:p>
-            <a:pPr algn="ctr" indent="0" marL="0">
-              <a:buNone/>
-            </a:pPr>
-            <a:r>
-              <a:rPr lang="en-US" sz="1400" b="1" dirty="0">
-                <a:solidFill>
-                  <a:srgbClr val="152536"/>
-                </a:solidFill>
-              </a:rPr>
-              <a:t>!</a:t>
-            </a:r>
-            <a:endParaRPr lang="en-US" sz="1400" dirty="0"/>
-          </a:p>
-        </p:txBody>
-      </p:sp>
-      <p:sp>
-        <p:nvSpPr>
-          <p:cNvPr id="20" name="Text 18"/>
-          <p:cNvSpPr txBox="1"/>
-          <p:nvPr/>
-        </p:nvSpPr>
-        <p:spPr>
-          <a:xfrm>
-            <a:off x="7078828" y="3368040"/>
-            <a:ext cx="4381348" cy="1310640"/>
-          </a:xfrm>
-          <a:prstGeom prst="rect">
-            <a:avLst/>
-          </a:prstGeom>
-          <a:noFill/>
-          <a:ln/>
-        </p:spPr>
-        <p:txBody>
-          <a:bodyPr wrap="square" lIns="0" tIns="0" rIns="0" bIns="0" rtlCol="0" anchor="ctr"/>
-          <a:lstStyle/>
-          <a:p>
-            <a:pPr indent="0" marL="0">
-              <a:buNone/>
-            </a:pPr>
-            <a:r>
-              <a:rPr lang="en-US" sz="1450" dirty="0">
-                <a:solidFill>
-                  <a:srgbClr val="F89820"/>
-                </a:solidFill>
-                <a:latin typeface="Consolas" pitchFamily="34" charset="0"/>
-                <a:ea typeface="Consolas" pitchFamily="34" charset="-122"/>
-                <a:cs typeface="Consolas" pitchFamily="34" charset="-120"/>
-              </a:rPr>
-              <a:t>Thread.sleep</a:t>
-            </a:r>
-            <a:r>
-              <a:rPr lang="en-US" sz="1450" dirty="0">
-                <a:solidFill>
-                  <a:srgbClr val="FFFFFF"/>
-                </a:solidFill>
-              </a:rPr>
-              <a:t> in a handler: a frozen window.</a:t>
-            </a:r>
-            <a:endParaRPr lang="en-US" sz="1450" dirty="0"/>
-          </a:p>
-        </p:txBody>
-      </p:sp>
-      <p:sp>
-        <p:nvSpPr>
-          <p:cNvPr id="21" name="Mistake 5"/>
-          <p:cNvSpPr/>
-          <p:nvPr/>
-        </p:nvSpPr>
-        <p:spPr>
-          <a:xfrm>
-            <a:off x="548640" y="4907280"/>
-            <a:ext cx="5387188" cy="1310640"/>
-          </a:xfrm>
-          <a:prstGeom prst="roundRect">
-            <a:avLst>
-              <a:gd name="adj" fmla="val 5581"/>
-            </a:avLst>
-          </a:prstGeom>
-          <a:solidFill>
-            <a:srgbClr val="22384F"/>
-          </a:solidFill>
-          <a:ln/>
-        </p:spPr>
-      </p:sp>
-      <p:sp>
-        <p:nvSpPr>
-          <p:cNvPr id="22" name="Shape 20"/>
-          <p:cNvSpPr/>
-          <p:nvPr/>
-        </p:nvSpPr>
-        <p:spPr>
-          <a:xfrm>
-            <a:off x="777240" y="5352288"/>
-            <a:ext cx="420624" cy="420624"/>
-          </a:xfrm>
-          <a:prstGeom prst="ellipse">
-            <a:avLst/>
-          </a:prstGeom>
-          <a:solidFill>
-            <a:srgbClr val="F89820"/>
-          </a:solidFill>
-          <a:ln/>
-        </p:spPr>
-      </p:sp>
-      <p:sp>
-        <p:nvSpPr>
-          <p:cNvPr id="23" name="Text 21"/>
-          <p:cNvSpPr txBox="1"/>
-          <p:nvPr/>
-        </p:nvSpPr>
-        <p:spPr>
-          <a:xfrm>
-            <a:off x="777240" y="5352288"/>
-            <a:ext cx="420624" cy="420624"/>
-          </a:xfrm>
-          <a:prstGeom prst="rect">
-            <a:avLst/>
-          </a:prstGeom>
-          <a:noFill/>
-          <a:ln/>
-        </p:spPr>
-        <p:txBody>
-          <a:bodyPr wrap="square" lIns="0" tIns="0" rIns="0" bIns="0" rtlCol="0" anchor="ctr"/>
-          <a:lstStyle/>
-          <a:p>
-            <a:pPr algn="ctr" indent="0" marL="0">
-              <a:buNone/>
-            </a:pPr>
-            <a:r>
-              <a:rPr lang="en-US" sz="1400" b="1" dirty="0">
-                <a:solidFill>
-                  <a:srgbClr val="152536"/>
-                </a:solidFill>
-              </a:rPr>
-              <a:t>!</a:t>
-            </a:r>
-            <a:endParaRPr lang="en-US" sz="1400" dirty="0"/>
-          </a:p>
-        </p:txBody>
-      </p:sp>
-      <p:sp>
-        <p:nvSpPr>
-          <p:cNvPr id="24" name="Text 22"/>
-          <p:cNvSpPr txBox="1"/>
-          <p:nvPr/>
-        </p:nvSpPr>
-        <p:spPr>
-          <a:xfrm>
-            <a:off x="1371600" y="4907280"/>
-            <a:ext cx="4381348" cy="1310640"/>
-          </a:xfrm>
-          <a:prstGeom prst="rect">
-            <a:avLst/>
-          </a:prstGeom>
-          <a:noFill/>
-          <a:ln/>
-        </p:spPr>
-        <p:txBody>
-          <a:bodyPr wrap="square" lIns="0" tIns="0" rIns="0" bIns="0" rtlCol="0" anchor="ctr"/>
-          <a:lstStyle/>
-          <a:p>
-            <a:pPr indent="0" marL="0">
-              <a:buNone/>
-            </a:pPr>
-            <a:r>
-              <a:rPr lang="en-US" sz="1450" dirty="0">
-                <a:solidFill>
-                  <a:srgbClr val="FFFFFF"/>
-                </a:solidFill>
-              </a:rPr>
-              <a:t>Uncaught exceptions in handlers.</a:t>
-            </a:r>
-            <a:endParaRPr lang="en-US" sz="1450" dirty="0"/>
-          </a:p>
-        </p:txBody>
-      </p:sp>
-      <p:sp>
-        <p:nvSpPr>
-          <p:cNvPr id="25" name="Mistake 6"/>
-          <p:cNvSpPr/>
-          <p:nvPr/>
-        </p:nvSpPr>
-        <p:spPr>
-          <a:xfrm>
-            <a:off x="6255868" y="4907280"/>
-            <a:ext cx="5387188" cy="1310640"/>
-          </a:xfrm>
-          <a:prstGeom prst="roundRect">
-            <a:avLst>
-              <a:gd name="adj" fmla="val 5581"/>
-            </a:avLst>
-          </a:prstGeom>
-          <a:solidFill>
-            <a:srgbClr val="22384F"/>
-          </a:solidFill>
-          <a:ln/>
-        </p:spPr>
-      </p:sp>
-      <p:sp>
-        <p:nvSpPr>
-          <p:cNvPr id="26" name="Shape 24"/>
-          <p:cNvSpPr/>
-          <p:nvPr/>
-        </p:nvSpPr>
-        <p:spPr>
-          <a:xfrm>
-            <a:off x="6484468" y="5352288"/>
-            <a:ext cx="420624" cy="420624"/>
-          </a:xfrm>
-          <a:prstGeom prst="ellipse">
-            <a:avLst/>
-          </a:prstGeom>
-          <a:solidFill>
-            <a:srgbClr val="F89820"/>
-          </a:solidFill>
-          <a:ln/>
-        </p:spPr>
-      </p:sp>
-      <p:sp>
-        <p:nvSpPr>
-          <p:cNvPr id="27" name="Text 25"/>
-          <p:cNvSpPr txBox="1"/>
-          <p:nvPr/>
-        </p:nvSpPr>
-        <p:spPr>
-          <a:xfrm>
-            <a:off x="6484468" y="5352288"/>
-            <a:ext cx="420624" cy="420624"/>
-          </a:xfrm>
-          <a:prstGeom prst="rect">
-            <a:avLst/>
-          </a:prstGeom>
-          <a:noFill/>
-          <a:ln/>
-        </p:spPr>
-        <p:txBody>
-          <a:bodyPr wrap="square" lIns="0" tIns="0" rIns="0" bIns="0" rtlCol="0" anchor="ctr"/>
-          <a:lstStyle/>
-          <a:p>
-            <a:pPr algn="ctr" indent="0" marL="0">
-              <a:buNone/>
-            </a:pPr>
-            <a:r>
-              <a:rPr lang="en-US" sz="1400" b="1" dirty="0">
-                <a:solidFill>
-                  <a:srgbClr val="152536"/>
-                </a:solidFill>
-              </a:rPr>
-              <a:t>!</a:t>
-            </a:r>
-            <a:endParaRPr lang="en-US" sz="1400" dirty="0"/>
-          </a:p>
-        </p:txBody>
-      </p:sp>
-      <p:sp>
-        <p:nvSpPr>
-          <p:cNvPr id="28" name="Text 26"/>
-          <p:cNvSpPr txBox="1"/>
-          <p:nvPr/>
-        </p:nvSpPr>
-        <p:spPr>
-          <a:xfrm>
-            <a:off x="7078828" y="4907280"/>
-            <a:ext cx="4381348" cy="1310640"/>
-          </a:xfrm>
-          <a:prstGeom prst="rect">
-            <a:avLst/>
-          </a:prstGeom>
-          <a:noFill/>
-          <a:ln/>
-        </p:spPr>
-        <p:txBody>
-          <a:bodyPr wrap="square" lIns="0" tIns="0" rIns="0" bIns="0" rtlCol="0" anchor="ctr"/>
-          <a:lstStyle/>
-          <a:p>
-            <a:pPr indent="0" marL="0">
-              <a:buNone/>
-            </a:pPr>
-            <a:r>
-              <a:rPr lang="en-US" sz="1450" dirty="0">
-                <a:solidFill>
-                  <a:srgbClr val="FFFFFF"/>
-                </a:solidFill>
-              </a:rPr>
-              <a:t>Changing a copy instead of the </a:t>
-            </a:r>
-            <a:r>
-              <a:rPr lang="en-US" sz="1450" dirty="0">
-                <a:solidFill>
-                  <a:srgbClr val="F89820"/>
-                </a:solidFill>
-                <a:latin typeface="Consolas" pitchFamily="34" charset="0"/>
-                <a:ea typeface="Consolas" pitchFamily="34" charset="-122"/>
-                <a:cs typeface="Consolas" pitchFamily="34" charset="-120"/>
-              </a:rPr>
-              <a:t>ObservableList</a:t>
-            </a:r>
-            <a:r>
-              <a:rPr lang="en-US" sz="1450" dirty="0">
-                <a:solidFill>
-                  <a:srgbClr val="FFFFFF"/>
-                </a:solidFill>
-              </a:rPr>
-              <a:t>.</a:t>
-            </a:r>
-            <a:endParaRPr lang="en-US" sz="1450" dirty="0"/>
+            <a:pPr marL="342900" indent="-342900">
+              <a:spcAft>
+                <a:spcPts val="1200"/>
+              </a:spcAft>
+              <a:buSzPct val="100000"/>
+              <a:buChar char="▸"/>
+            </a:pPr>
+            <a:r>
+              <a:rPr lang="en-US" sz="1650" dirty="0">
+                <a:solidFill>
+                  <a:srgbClr val="1F2933"/>
+                </a:solidFill>
+              </a:rPr>
+              <a:t>Modules 14b, 17 and 18 in one app.</a:t>
+            </a:r>
+            <a:endParaRPr lang="en-US" sz="1650" dirty="0"/>
+          </a:p>
+          <a:p>
+            <a:pPr marL="342900" indent="-342900">
+              <a:spcAft>
+                <a:spcPts val="1200"/>
+              </a:spcAft>
+              <a:buSzPct val="100000"/>
+              <a:buChar char="▸"/>
+            </a:pPr>
+            <a:r>
+              <a:rPr lang="en-US" sz="1650" dirty="0">
+                <a:solidFill>
+                  <a:srgbClr val="1F2933"/>
+                </a:solidFill>
+              </a:rPr>
+              <a:t>Each action: form → repository → refresh.</a:t>
+            </a:r>
+            <a:endParaRPr lang="en-US" sz="1650" dirty="0"/>
+          </a:p>
+          <a:p>
+            <a:pPr marL="342900" indent="-342900">
+              <a:spcAft>
+                <a:spcPts val="1200"/>
+              </a:spcAft>
+              <a:buSzPct val="100000"/>
+              <a:buChar char="▸"/>
+            </a:pPr>
+            <a:r>
+              <a:rPr lang="en-US" sz="1650" dirty="0">
+                <a:solidFill>
+                  <a:srgbClr val="1F2933"/>
+                </a:solidFill>
+              </a:rPr>
+              <a:t>Also runs with the JavaFX SDK.</a:t>
+            </a:r>
+            <a:endParaRPr lang="en-US" sz="1650" dirty="0"/>
           </a:p>
         </p:txBody>
       </p:sp>
@@ -3331,7 +3096,7 @@
             <a:lvl1pPr>
               <a:defRPr sz="900">
                 <a:solidFill>
-                  <a:srgbClr val="7F93AD"/>
+                  <a:srgbClr val="8A97A8"/>
                 </a:solidFill>
               </a:defRPr>
             </a:lvl1pPr>
@@ -3380,7 +3145,7 @@
         <p:spPr>
           <a:xfrm>
             <a:off x="548640" y="411480"/>
-            <a:ext cx="1714500" cy="310896"/>
+            <a:ext cx="1193292" cy="310896"/>
           </a:xfrm>
           <a:prstGeom prst="roundRect">
             <a:avLst>
@@ -3388,7 +3153,7 @@
             </a:avLst>
           </a:prstGeom>
           <a:solidFill>
-            <a:srgbClr val="2F6F9F"/>
+            <a:srgbClr val="F89820"/>
           </a:solidFill>
           <a:ln/>
         </p:spPr>
@@ -3402,7 +3167,7 @@
         <p:spPr>
           <a:xfrm>
             <a:off x="548640" y="411480"/>
-            <a:ext cx="1714500" cy="310896"/>
+            <a:ext cx="1193292" cy="310896"/>
           </a:xfrm>
           <a:prstGeom prst="rect">
             <a:avLst/>
@@ -3420,10 +3185,10 @@
             <a:r>
               <a:rPr lang="en-US" sz="1050" b="1" spc="150" kern="0" dirty="0">
                 <a:solidFill>
-                  <a:srgbClr val="FFFFFF"/>
-                </a:solidFill>
-              </a:rPr>
-              <a:t>TRY IT YOURSELF</a:t>
+                  <a:srgbClr val="152536"/>
+                </a:solidFill>
+              </a:rPr>
+              <a:t>WATCH OUT</a:t>
             </a:r>
             <a:endParaRPr lang="en-US" sz="1050" dirty="0"/>
           </a:p>
@@ -3458,13 +3223,13 @@
             <a:r>
               <a:rPr lang="en-US" sz="3200" b="1" dirty="0">
                 <a:solidFill>
-                  <a:srgbClr val="14273E"/>
+                  <a:srgbClr val="FFFFFF"/>
                 </a:solidFill>
                 <a:latin typeface="Cambria" pitchFamily="34" charset="0"/>
                 <a:ea typeface="Cambria" pitchFamily="34" charset="-122"/>
                 <a:cs typeface="Cambria" pitchFamily="34" charset="-120"/>
               </a:rPr>
-              <a:t>Before you move on</a:t>
+              <a:t>Common beginner mistakes</a:t>
             </a:r>
             <a:endParaRPr lang="en-US" sz="3200" dirty="0"/>
           </a:p>
@@ -3472,34 +3237,56 @@
       </p:sp>
       <p:sp>
         <p:nvSpPr>
-          <p:cNvPr id="5" name="Shape 3"/>
+          <p:cNvPr id="5" name="Mistake 1"/>
           <p:cNvSpPr/>
           <p:nvPr/>
         </p:nvSpPr>
         <p:spPr>
           <a:xfrm>
-            <a:off x="548640" y="2011680"/>
-            <a:ext cx="457200" cy="457200"/>
+            <a:off x="548640" y="1828800"/>
+            <a:ext cx="5387188" cy="1310640"/>
+          </a:xfrm>
+          <a:prstGeom prst="roundRect">
+            <a:avLst>
+              <a:gd name="adj" fmla="val 5581"/>
+            </a:avLst>
+          </a:prstGeom>
+          <a:solidFill>
+            <a:srgbClr val="22384F"/>
+          </a:solidFill>
+          <a:ln/>
+        </p:spPr>
+      </p:sp>
+      <p:sp>
+        <p:nvSpPr>
+          <p:cNvPr id="6" name="Shape 4"/>
+          <p:cNvSpPr/>
+          <p:nvPr/>
+        </p:nvSpPr>
+        <p:spPr>
+          <a:xfrm>
+            <a:off x="777240" y="2273808"/>
+            <a:ext cx="420624" cy="420624"/>
           </a:xfrm>
           <a:prstGeom prst="ellipse">
             <a:avLst/>
           </a:prstGeom>
           <a:solidFill>
-            <a:srgbClr val="2F6F9F"/>
+            <a:srgbClr val="F89820"/>
           </a:solidFill>
           <a:ln/>
         </p:spPr>
       </p:sp>
       <p:sp>
         <p:nvSpPr>
-          <p:cNvPr id="6" name="Text 4"/>
+          <p:cNvPr id="7" name="Text 5"/>
           <p:cNvSpPr txBox="1"/>
           <p:nvPr/>
         </p:nvSpPr>
         <p:spPr>
           <a:xfrm>
-            <a:off x="548640" y="2011680"/>
-            <a:ext cx="457200" cy="457200"/>
+            <a:off x="777240" y="2273808"/>
+            <a:ext cx="420624" cy="420624"/>
           </a:xfrm>
           <a:prstGeom prst="rect">
             <a:avLst/>
@@ -3517,10 +3304,10 @@
             <a:r>
               <a:rPr lang="en-US" sz="1400" b="1" dirty="0">
                 <a:solidFill>
-                  <a:srgbClr val="FFFFFF"/>
-                </a:solidFill>
-              </a:rPr>
-              <a:t>1</a:t>
+                  <a:srgbClr val="152536"/>
+                </a:solidFill>
+              </a:rPr>
+              <a:t>!</a:t>
             </a:r>
             <a:endParaRPr lang="en-US" sz="1400" dirty="0"/>
           </a:p>
@@ -3528,14 +3315,14 @@
       </p:sp>
       <p:sp>
         <p:nvSpPr>
-          <p:cNvPr id="7" name="Text 5"/>
+          <p:cNvPr id="8" name="Text 6"/>
           <p:cNvSpPr txBox="1"/>
           <p:nvPr/>
         </p:nvSpPr>
         <p:spPr>
           <a:xfrm>
-            <a:off x="1234440" y="1828800"/>
-            <a:ext cx="6035040" cy="822960"/>
+            <a:off x="1371600" y="1828800"/>
+            <a:ext cx="4381348" cy="1310640"/>
           </a:xfrm>
           <a:prstGeom prst="rect">
             <a:avLst/>
@@ -3551,47 +3338,69 @@
               <a:buNone/>
             </a:pPr>
             <a:r>
-              <a:rPr lang="en-US" sz="1600" dirty="0">
-                <a:solidFill>
-                  <a:srgbClr val="1F2933"/>
-                </a:solidFill>
-              </a:rPr>
-              <a:t>Run every example; add a bonus dot to the hook.</a:t>
-            </a:r>
-            <a:endParaRPr lang="en-US" sz="1600" dirty="0"/>
+              <a:rPr lang="en-US" sz="1450" dirty="0">
+                <a:solidFill>
+                  <a:srgbClr val="FFFFFF"/>
+                </a:solidFill>
+              </a:rPr>
+              <a:t>"JavaFX runtime components are missing".</a:t>
+            </a:r>
+            <a:endParaRPr lang="en-US" sz="1450" dirty="0"/>
           </a:p>
         </p:txBody>
       </p:sp>
       <p:sp>
         <p:nvSpPr>
-          <p:cNvPr id="8" name="Shape 6"/>
+          <p:cNvPr id="9" name="Mistake 2"/>
           <p:cNvSpPr/>
           <p:nvPr/>
         </p:nvSpPr>
         <p:spPr>
           <a:xfrm>
-            <a:off x="548640" y="2926080"/>
-            <a:ext cx="457200" cy="457200"/>
+            <a:off x="6255868" y="1828800"/>
+            <a:ext cx="5387188" cy="1310640"/>
+          </a:xfrm>
+          <a:prstGeom prst="roundRect">
+            <a:avLst>
+              <a:gd name="adj" fmla="val 5581"/>
+            </a:avLst>
+          </a:prstGeom>
+          <a:solidFill>
+            <a:srgbClr val="22384F"/>
+          </a:solidFill>
+          <a:ln/>
+        </p:spPr>
+      </p:sp>
+      <p:sp>
+        <p:nvSpPr>
+          <p:cNvPr id="10" name="Shape 8"/>
+          <p:cNvSpPr/>
+          <p:nvPr/>
+        </p:nvSpPr>
+        <p:spPr>
+          <a:xfrm>
+            <a:off x="6484468" y="2273808"/>
+            <a:ext cx="420624" cy="420624"/>
           </a:xfrm>
           <a:prstGeom prst="ellipse">
             <a:avLst/>
           </a:prstGeom>
           <a:solidFill>
-            <a:srgbClr val="2F6F9F"/>
+            <a:srgbClr val="F89820"/>
           </a:solidFill>
           <a:ln/>
         </p:spPr>
       </p:sp>
       <p:sp>
         <p:nvSpPr>
-          <p:cNvPr id="9" name="Text 7"/>
+          <p:cNvPr id="11" name="Text 9"/>
           <p:cNvSpPr txBox="1"/>
           <p:nvPr/>
         </p:nvSpPr>
         <p:spPr>
           <a:xfrm>
-            <a:off x="548640" y="2926080"/>
-            <a:ext cx="457200" cy="457200"/>
+            <a:off x="6484468" y="2273808"/>
+            <a:ext cx="420624" cy="420624"/>
           </a:xfrm>
           <a:prstGeom prst="rect">
             <a:avLst/>
@@ -3609,10 +3418,10 @@
             <a:r>
               <a:rPr lang="en-US" sz="1400" b="1" dirty="0">
                 <a:solidFill>
-                  <a:srgbClr val="FFFFFF"/>
-                </a:solidFill>
-              </a:rPr>
-              <a:t>2</a:t>
+                  <a:srgbClr val="152536"/>
+                </a:solidFill>
+              </a:rPr>
+              <a:t>!</a:t>
             </a:r>
             <a:endParaRPr lang="en-US" sz="1400" dirty="0"/>
           </a:p>
@@ -3620,14 +3429,14 @@
       </p:sp>
       <p:sp>
         <p:nvSpPr>
-          <p:cNvPr id="10" name="Text 8"/>
+          <p:cNvPr id="12" name="Text 10"/>
           <p:cNvSpPr txBox="1"/>
           <p:nvPr/>
         </p:nvSpPr>
         <p:spPr>
           <a:xfrm>
-            <a:off x="1234440" y="2743200"/>
-            <a:ext cx="6035040" cy="822960"/>
+            <a:off x="7078828" y="1828800"/>
+            <a:ext cx="4381348" cy="1310640"/>
           </a:xfrm>
           <a:prstGeom prst="rect">
             <a:avLst/>
@@ -3643,47 +3452,88 @@
               <a:buNone/>
             </a:pPr>
             <a:r>
-              <a:rPr lang="en-US" sz="1600" dirty="0">
-                <a:solidFill>
-                  <a:srgbClr val="1F2933"/>
-                </a:solidFill>
-              </a:rPr>
-              <a:t>Exercise 1: a unit converter, with a binding.</a:t>
-            </a:r>
-            <a:endParaRPr lang="en-US" sz="1600" dirty="0"/>
+              <a:rPr lang="en-US" sz="1450" dirty="0">
+                <a:solidFill>
+                  <a:srgbClr val="FFFFFF"/>
+                </a:solidFill>
+              </a:rPr>
+              <a:t>Forgetting </a:t>
+            </a:r>
+            <a:r>
+              <a:rPr lang="en-US" sz="1450" dirty="0">
+                <a:solidFill>
+                  <a:srgbClr val="F89820"/>
+                </a:solidFill>
+                <a:latin typeface="Consolas" pitchFamily="34" charset="0"/>
+                <a:ea typeface="Consolas" pitchFamily="34" charset="-122"/>
+                <a:cs typeface="Consolas" pitchFamily="34" charset="-120"/>
+              </a:rPr>
+              <a:t>stage.show()</a:t>
+            </a:r>
+            <a:r>
+              <a:rPr lang="en-US" sz="1450" dirty="0">
+                <a:solidFill>
+                  <a:srgbClr val="FFFFFF"/>
+                </a:solidFill>
+              </a:rPr>
+              <a:t>.</a:t>
+            </a:r>
+            <a:endParaRPr lang="en-US" sz="1450" dirty="0"/>
           </a:p>
         </p:txBody>
       </p:sp>
       <p:sp>
         <p:nvSpPr>
-          <p:cNvPr id="11" name="Shape 9"/>
+          <p:cNvPr id="13" name="Mistake 3"/>
           <p:cNvSpPr/>
           <p:nvPr/>
         </p:nvSpPr>
         <p:spPr>
           <a:xfrm>
-            <a:off x="548640" y="3840480"/>
-            <a:ext cx="457200" cy="457200"/>
+            <a:off x="548640" y="3368040"/>
+            <a:ext cx="5387188" cy="1310640"/>
+          </a:xfrm>
+          <a:prstGeom prst="roundRect">
+            <a:avLst>
+              <a:gd name="adj" fmla="val 5581"/>
+            </a:avLst>
+          </a:prstGeom>
+          <a:solidFill>
+            <a:srgbClr val="22384F"/>
+          </a:solidFill>
+          <a:ln/>
+        </p:spPr>
+      </p:sp>
+      <p:sp>
+        <p:nvSpPr>
+          <p:cNvPr id="14" name="Shape 12"/>
+          <p:cNvSpPr/>
+          <p:nvPr/>
+        </p:nvSpPr>
+        <p:spPr>
+          <a:xfrm>
+            <a:off x="777240" y="3813048"/>
+            <a:ext cx="420624" cy="420624"/>
           </a:xfrm>
           <a:prstGeom prst="ellipse">
             <a:avLst/>
           </a:prstGeom>
           <a:solidFill>
-            <a:srgbClr val="2F6F9F"/>
+            <a:srgbClr val="F89820"/>
           </a:solidFill>
           <a:ln/>
         </p:spPr>
       </p:sp>
       <p:sp>
         <p:nvSpPr>
-          <p:cNvPr id="12" name="Text 10"/>
+          <p:cNvPr id="15" name="Text 13"/>
           <p:cNvSpPr txBox="1"/>
           <p:nvPr/>
         </p:nvSpPr>
         <p:spPr>
           <a:xfrm>
-            <a:off x="548640" y="3840480"/>
-            <a:ext cx="457200" cy="457200"/>
+            <a:off x="777240" y="3813048"/>
+            <a:ext cx="420624" cy="420624"/>
           </a:xfrm>
           <a:prstGeom prst="rect">
             <a:avLst/>
@@ -3701,10 +3551,10 @@
             <a:r>
               <a:rPr lang="en-US" sz="1400" b="1" dirty="0">
                 <a:solidFill>
-                  <a:srgbClr val="FFFFFF"/>
-                </a:solidFill>
-              </a:rPr>
-              <a:t>3</a:t>
+                  <a:srgbClr val="152536"/>
+                </a:solidFill>
+              </a:rPr>
+              <a:t>!</a:t>
             </a:r>
             <a:endParaRPr lang="en-US" sz="1400" dirty="0"/>
           </a:p>
@@ -3712,14 +3562,14 @@
       </p:sp>
       <p:sp>
         <p:nvSpPr>
-          <p:cNvPr id="13" name="Text 11"/>
+          <p:cNvPr id="16" name="Text 14"/>
           <p:cNvSpPr txBox="1"/>
           <p:nvPr/>
         </p:nvSpPr>
         <p:spPr>
           <a:xfrm>
-            <a:off x="1234440" y="3657600"/>
-            <a:ext cx="6035040" cy="822960"/>
+            <a:off x="1371600" y="3368040"/>
+            <a:ext cx="4381348" cy="1310640"/>
           </a:xfrm>
           <a:prstGeom prst="rect">
             <a:avLst/>
@@ -3735,47 +3585,69 @@
               <a:buNone/>
             </a:pPr>
             <a:r>
-              <a:rPr lang="en-US" sz="1600" dirty="0">
-                <a:solidFill>
-                  <a:srgbClr val="1F2933"/>
-                </a:solidFill>
-              </a:rPr>
-              <a:t>Exercise 2: a calculator model that passes 16 tests.</a:t>
-            </a:r>
-            <a:endParaRPr lang="en-US" sz="1600" dirty="0"/>
+              <a:rPr lang="en-US" sz="1450" dirty="0">
+                <a:solidFill>
+                  <a:srgbClr val="FFFFFF"/>
+                </a:solidFill>
+              </a:rPr>
+              <a:t>A node never added to a pane, or added twice.</a:t>
+            </a:r>
+            <a:endParaRPr lang="en-US" sz="1450" dirty="0"/>
           </a:p>
         </p:txBody>
       </p:sp>
       <p:sp>
         <p:nvSpPr>
-          <p:cNvPr id="14" name="Shape 12"/>
+          <p:cNvPr id="17" name="Mistake 4"/>
           <p:cNvSpPr/>
           <p:nvPr/>
         </p:nvSpPr>
         <p:spPr>
           <a:xfrm>
-            <a:off x="548640" y="4754880"/>
-            <a:ext cx="457200" cy="457200"/>
+            <a:off x="6255868" y="3368040"/>
+            <a:ext cx="5387188" cy="1310640"/>
+          </a:xfrm>
+          <a:prstGeom prst="roundRect">
+            <a:avLst>
+              <a:gd name="adj" fmla="val 5581"/>
+            </a:avLst>
+          </a:prstGeom>
+          <a:solidFill>
+            <a:srgbClr val="22384F"/>
+          </a:solidFill>
+          <a:ln/>
+        </p:spPr>
+      </p:sp>
+      <p:sp>
+        <p:nvSpPr>
+          <p:cNvPr id="18" name="Shape 16"/>
+          <p:cNvSpPr/>
+          <p:nvPr/>
+        </p:nvSpPr>
+        <p:spPr>
+          <a:xfrm>
+            <a:off x="6484468" y="3813048"/>
+            <a:ext cx="420624" cy="420624"/>
           </a:xfrm>
           <a:prstGeom prst="ellipse">
             <a:avLst/>
           </a:prstGeom>
           <a:solidFill>
-            <a:srgbClr val="2F6F9F"/>
+            <a:srgbClr val="F89820"/>
           </a:solidFill>
           <a:ln/>
         </p:spPr>
       </p:sp>
       <p:sp>
         <p:nvSpPr>
-          <p:cNvPr id="15" name="Text 13"/>
+          <p:cNvPr id="19" name="Text 17"/>
           <p:cNvSpPr txBox="1"/>
           <p:nvPr/>
         </p:nvSpPr>
         <p:spPr>
           <a:xfrm>
-            <a:off x="548640" y="4754880"/>
-            <a:ext cx="457200" cy="457200"/>
+            <a:off x="6484468" y="3813048"/>
+            <a:ext cx="420624" cy="420624"/>
           </a:xfrm>
           <a:prstGeom prst="rect">
             <a:avLst/>
@@ -3793,10 +3665,10 @@
             <a:r>
               <a:rPr lang="en-US" sz="1400" b="1" dirty="0">
                 <a:solidFill>
-                  <a:srgbClr val="FFFFFF"/>
-                </a:solidFill>
-              </a:rPr>
-              <a:t>4</a:t>
+                  <a:srgbClr val="152536"/>
+                </a:solidFill>
+              </a:rPr>
+              <a:t>!</a:t>
             </a:r>
             <a:endParaRPr lang="en-US" sz="1400" dirty="0"/>
           </a:p>
@@ -3804,14 +3676,14 @@
       </p:sp>
       <p:sp>
         <p:nvSpPr>
-          <p:cNvPr id="16" name="Text 14"/>
+          <p:cNvPr id="20" name="Text 18"/>
           <p:cNvSpPr txBox="1"/>
           <p:nvPr/>
         </p:nvSpPr>
         <p:spPr>
           <a:xfrm>
-            <a:off x="1234440" y="4572000"/>
-            <a:ext cx="6035040" cy="822960"/>
+            <a:off x="7078828" y="3368040"/>
+            <a:ext cx="4381348" cy="1310640"/>
           </a:xfrm>
           <a:prstGeom prst="rect">
             <a:avLst/>
@@ -3827,49 +3699,80 @@
               <a:buNone/>
             </a:pPr>
             <a:r>
-              <a:rPr lang="en-US" sz="1600" dirty="0">
-                <a:solidFill>
-                  <a:srgbClr val="1F2933"/>
-                </a:solidFill>
-              </a:rPr>
-              <a:t>Build the project in your track.</a:t>
-            </a:r>
-            <a:endParaRPr lang="en-US" sz="1600" dirty="0"/>
+              <a:rPr lang="en-US" sz="1450" dirty="0">
+                <a:solidFill>
+                  <a:srgbClr val="F89820"/>
+                </a:solidFill>
+                <a:latin typeface="Consolas" pitchFamily="34" charset="0"/>
+                <a:ea typeface="Consolas" pitchFamily="34" charset="-122"/>
+                <a:cs typeface="Consolas" pitchFamily="34" charset="-120"/>
+              </a:rPr>
+              <a:t>Thread.sleep</a:t>
+            </a:r>
+            <a:r>
+              <a:rPr lang="en-US" sz="1450" dirty="0">
+                <a:solidFill>
+                  <a:srgbClr val="FFFFFF"/>
+                </a:solidFill>
+              </a:rPr>
+              <a:t> in a handler: a frozen window.</a:t>
+            </a:r>
+            <a:endParaRPr lang="en-US" sz="1450" dirty="0"/>
           </a:p>
         </p:txBody>
       </p:sp>
       <p:sp>
         <p:nvSpPr>
-          <p:cNvPr id="17" name="Project card"/>
+          <p:cNvPr id="21" name="Mistake 5"/>
           <p:cNvSpPr/>
           <p:nvPr/>
         </p:nvSpPr>
         <p:spPr>
           <a:xfrm>
-            <a:off x="7589520" y="1828800"/>
-            <a:ext cx="4053535" cy="4297680"/>
+            <a:off x="548640" y="4907280"/>
+            <a:ext cx="5387188" cy="1310640"/>
           </a:xfrm>
           <a:prstGeom prst="roundRect">
             <a:avLst>
-              <a:gd name="adj" fmla="val 2707"/>
+              <a:gd name="adj" fmla="val 5581"/>
             </a:avLst>
           </a:prstGeom>
           <a:solidFill>
-            <a:srgbClr val="152536"/>
+            <a:srgbClr val="22384F"/>
           </a:solidFill>
           <a:ln/>
         </p:spPr>
       </p:sp>
       <p:sp>
         <p:nvSpPr>
-          <p:cNvPr id="18" name="Text 16"/>
+          <p:cNvPr id="22" name="Shape 20"/>
+          <p:cNvSpPr/>
+          <p:nvPr/>
+        </p:nvSpPr>
+        <p:spPr>
+          <a:xfrm>
+            <a:off x="777240" y="5352288"/>
+            <a:ext cx="420624" cy="420624"/>
+          </a:xfrm>
+          <a:prstGeom prst="ellipse">
+            <a:avLst/>
+          </a:prstGeom>
+          <a:solidFill>
+            <a:srgbClr val="F89820"/>
+          </a:solidFill>
+          <a:ln/>
+        </p:spPr>
+      </p:sp>
+      <p:sp>
+        <p:nvSpPr>
+          <p:cNvPr id="23" name="Text 21"/>
           <p:cNvSpPr txBox="1"/>
           <p:nvPr/>
         </p:nvSpPr>
         <p:spPr>
           <a:xfrm>
-            <a:off x="7909560" y="2103120"/>
-            <a:ext cx="3413455" cy="320040"/>
+            <a:off x="777240" y="5352288"/>
+            <a:ext cx="420624" cy="420624"/>
           </a:xfrm>
           <a:prstGeom prst="rect">
             <a:avLst/>
@@ -3881,106 +3784,31 @@
           <a:bodyPr wrap="square" lIns="0" tIns="0" rIns="0" bIns="0" rtlCol="0" anchor="ctr"/>
           <a:lstStyle/>
           <a:p>
-            <a:pPr indent="0" marL="0">
+            <a:pPr algn="ctr" indent="0" marL="0">
               <a:buNone/>
             </a:pPr>
             <a:r>
-              <a:rPr lang="en-US" sz="1100" b="1" spc="200" kern="0" dirty="0">
-                <a:solidFill>
-                  <a:srgbClr val="F89820"/>
-                </a:solidFill>
-              </a:rPr>
-              <a:t>MODULE PROJECT</a:t>
-            </a:r>
-            <a:endParaRPr lang="en-US" sz="1100" dirty="0"/>
+              <a:rPr lang="en-US" sz="1400" b="1" dirty="0">
+                <a:solidFill>
+                  <a:srgbClr val="152536"/>
+                </a:solidFill>
+              </a:rPr>
+              <a:t>!</a:t>
+            </a:r>
+            <a:endParaRPr lang="en-US" sz="1400" dirty="0"/>
           </a:p>
         </p:txBody>
       </p:sp>
       <p:sp>
         <p:nvSpPr>
-          <p:cNvPr id="19" name="Text 17"/>
+          <p:cNvPr id="24" name="Text 22"/>
           <p:cNvSpPr txBox="1"/>
           <p:nvPr/>
         </p:nvSpPr>
         <p:spPr>
           <a:xfrm>
-            <a:off x="7909560" y="2468880"/>
-            <a:ext cx="3413455" cy="1005840"/>
-          </a:xfrm>
-          <a:prstGeom prst="rect">
-            <a:avLst/>
-          </a:prstGeom>
-          <a:noFill/>
-          <a:ln/>
-        </p:spPr>
-        <p:txBody>
-          <a:bodyPr wrap="square" lIns="0" tIns="0" rIns="0" bIns="0" rtlCol="0" anchor="t"/>
-          <a:lstStyle/>
-          <a:p>
-            <a:pPr indent="0" marL="0">
-              <a:buNone/>
-            </a:pPr>
-            <a:r>
-              <a:rPr lang="en-US" sz="2400" b="1" dirty="0">
-                <a:solidFill>
-                  <a:srgbClr val="FFFFFF"/>
-                </a:solidFill>
-                <a:latin typeface="Cambria" pitchFamily="34" charset="0"/>
-                <a:ea typeface="Cambria" pitchFamily="34" charset="-122"/>
-                <a:cs typeface="Cambria" pitchFamily="34" charset="-120"/>
-              </a:rPr>
-              <a:t>A Real Windowed Application</a:t>
-            </a:r>
-            <a:endParaRPr lang="en-US" sz="2400" dirty="0"/>
-          </a:p>
-        </p:txBody>
-      </p:sp>
-      <p:sp>
-        <p:nvSpPr>
-          <p:cNvPr id="20" name="Text 18"/>
-          <p:cNvSpPr txBox="1"/>
-          <p:nvPr/>
-        </p:nvSpPr>
-        <p:spPr>
-          <a:xfrm>
-            <a:off x="7909560" y="3566160"/>
-            <a:ext cx="3413455" cy="1920240"/>
-          </a:xfrm>
-          <a:prstGeom prst="rect">
-            <a:avLst/>
-          </a:prstGeom>
-          <a:noFill/>
-          <a:ln/>
-        </p:spPr>
-        <p:txBody>
-          <a:bodyPr wrap="square" lIns="0" tIns="0" rIns="0" bIns="0" rtlCol="0" anchor="t"/>
-          <a:lstStyle/>
-          <a:p>
-            <a:pPr indent="0" marL="0">
-              <a:buNone/>
-            </a:pPr>
-            <a:r>
-              <a:rPr lang="en-US" sz="1450" dirty="0">
-                <a:solidFill>
-                  <a:srgbClr val="DCE4EE"/>
-                </a:solidFill>
-              </a:rPr>
-              <a:t>Track A: a study planner with a TableView. Track B: a resistor colour code calculator with a drawn resistor. Track C: a vitals dashboard with a LineChart.</a:t>
-            </a:r>
-            <a:endParaRPr lang="en-US" sz="1450" dirty="0"/>
-          </a:p>
-        </p:txBody>
-      </p:sp>
-      <p:sp>
-        <p:nvSpPr>
-          <p:cNvPr id="21" name="Text 19"/>
-          <p:cNvSpPr txBox="1"/>
-          <p:nvPr/>
-        </p:nvSpPr>
-        <p:spPr>
-          <a:xfrm>
-            <a:off x="7909560" y="5577840"/>
-            <a:ext cx="3413455" cy="365760"/>
+            <a:off x="1371600" y="4907280"/>
+            <a:ext cx="4381348" cy="1310640"/>
           </a:xfrm>
           <a:prstGeom prst="rect">
             <a:avLst/>
@@ -3996,14 +3824,147 @@
               <a:buNone/>
             </a:pPr>
             <a:r>
-              <a:rPr lang="en-US" sz="1250" b="1" dirty="0">
+              <a:rPr lang="en-US" sz="1450" dirty="0">
+                <a:solidFill>
+                  <a:srgbClr val="FFFFFF"/>
+                </a:solidFill>
+              </a:rPr>
+              <a:t>Uncaught exceptions in handlers.</a:t>
+            </a:r>
+            <a:endParaRPr lang="en-US" sz="1450" dirty="0"/>
+          </a:p>
+        </p:txBody>
+      </p:sp>
+      <p:sp>
+        <p:nvSpPr>
+          <p:cNvPr id="25" name="Mistake 6"/>
+          <p:cNvSpPr/>
+          <p:nvPr/>
+        </p:nvSpPr>
+        <p:spPr>
+          <a:xfrm>
+            <a:off x="6255868" y="4907280"/>
+            <a:ext cx="5387188" cy="1310640"/>
+          </a:xfrm>
+          <a:prstGeom prst="roundRect">
+            <a:avLst>
+              <a:gd name="adj" fmla="val 5581"/>
+            </a:avLst>
+          </a:prstGeom>
+          <a:solidFill>
+            <a:srgbClr val="22384F"/>
+          </a:solidFill>
+          <a:ln/>
+        </p:spPr>
+      </p:sp>
+      <p:sp>
+        <p:nvSpPr>
+          <p:cNvPr id="26" name="Shape 24"/>
+          <p:cNvSpPr/>
+          <p:nvPr/>
+        </p:nvSpPr>
+        <p:spPr>
+          <a:xfrm>
+            <a:off x="6484468" y="5352288"/>
+            <a:ext cx="420624" cy="420624"/>
+          </a:xfrm>
+          <a:prstGeom prst="ellipse">
+            <a:avLst/>
+          </a:prstGeom>
+          <a:solidFill>
+            <a:srgbClr val="F89820"/>
+          </a:solidFill>
+          <a:ln/>
+        </p:spPr>
+      </p:sp>
+      <p:sp>
+        <p:nvSpPr>
+          <p:cNvPr id="27" name="Text 25"/>
+          <p:cNvSpPr txBox="1"/>
+          <p:nvPr/>
+        </p:nvSpPr>
+        <p:spPr>
+          <a:xfrm>
+            <a:off x="6484468" y="5352288"/>
+            <a:ext cx="420624" cy="420624"/>
+          </a:xfrm>
+          <a:prstGeom prst="rect">
+            <a:avLst/>
+          </a:prstGeom>
+          <a:noFill/>
+          <a:ln/>
+        </p:spPr>
+        <p:txBody>
+          <a:bodyPr wrap="square" lIns="0" tIns="0" rIns="0" bIns="0" rtlCol="0" anchor="ctr"/>
+          <a:lstStyle/>
+          <a:p>
+            <a:pPr algn="ctr" indent="0" marL="0">
+              <a:buNone/>
+            </a:pPr>
+            <a:r>
+              <a:rPr lang="en-US" sz="1400" b="1" dirty="0">
+                <a:solidFill>
+                  <a:srgbClr val="152536"/>
+                </a:solidFill>
+              </a:rPr>
+              <a:t>!</a:t>
+            </a:r>
+            <a:endParaRPr lang="en-US" sz="1400" dirty="0"/>
+          </a:p>
+        </p:txBody>
+      </p:sp>
+      <p:sp>
+        <p:nvSpPr>
+          <p:cNvPr id="28" name="Text 26"/>
+          <p:cNvSpPr txBox="1"/>
+          <p:nvPr/>
+        </p:nvSpPr>
+        <p:spPr>
+          <a:xfrm>
+            <a:off x="7078828" y="4907280"/>
+            <a:ext cx="4381348" cy="1310640"/>
+          </a:xfrm>
+          <a:prstGeom prst="rect">
+            <a:avLst/>
+          </a:prstGeom>
+          <a:noFill/>
+          <a:ln/>
+        </p:spPr>
+        <p:txBody>
+          <a:bodyPr wrap="square" lIns="0" tIns="0" rIns="0" bIns="0" rtlCol="0" anchor="ctr"/>
+          <a:lstStyle/>
+          <a:p>
+            <a:pPr indent="0" marL="0">
+              <a:buNone/>
+            </a:pPr>
+            <a:r>
+              <a:rPr lang="en-US" sz="1450" dirty="0">
+                <a:solidFill>
+                  <a:srgbClr val="FFFFFF"/>
+                </a:solidFill>
+              </a:rPr>
+              <a:t>Changing a copy instead of the </a:t>
+            </a:r>
+            <a:r>
+              <a:rPr lang="en-US" sz="1450" dirty="0">
                 <a:solidFill>
                   <a:srgbClr val="F89820"/>
                 </a:solidFill>
-              </a:rPr>
-              <a:t>Next: Module 19, Capstone 2</a:t>
-            </a:r>
-            <a:endParaRPr lang="en-US" sz="1250" dirty="0"/>
+                <a:latin typeface="Consolas" pitchFamily="34" charset="0"/>
+                <a:ea typeface="Consolas" pitchFamily="34" charset="-122"/>
+                <a:cs typeface="Consolas" pitchFamily="34" charset="-120"/>
+              </a:rPr>
+              <a:t>ObservableList</a:t>
+            </a:r>
+            <a:r>
+              <a:rPr lang="en-US" sz="1450" dirty="0">
+                <a:solidFill>
+                  <a:srgbClr val="FFFFFF"/>
+                </a:solidFill>
+              </a:rPr>
+              <a:t>.</a:t>
+            </a:r>
+            <a:endParaRPr lang="en-US" sz="1450" dirty="0"/>
           </a:p>
         </p:txBody>
       </p:sp>
@@ -4037,7 +3998,7 @@
             <a:lvl1pPr>
               <a:defRPr sz="900">
                 <a:solidFill>
-                  <a:srgbClr val="8A97A8"/>
+                  <a:srgbClr val="7F93AD"/>
                 </a:solidFill>
               </a:defRPr>
             </a:lvl1pPr>
@@ -4047,6 +4008,712 @@
             <a:fld id="{F7021451-1387-4CA6-816F-3879F97B5CBC}" type="slidenum">
               <a:rPr b="0" lang="en-US"/>
               <a:t>11</a:t>
+            </a:fld>
+            <a:endParaRPr lang="en-US"/>
+          </a:p>
+        </p:txBody>
+      </p:sp>
+    </p:spTree>
+  </p:cSld>
+  <p:clrMapOvr>
+    <a:masterClrMapping/>
+  </p:clrMapOvr>
+</p:sld>
+</file>
+
+<file path=ppt/slides/slide12.xml><?xml version="1.0" encoding="utf-8"?>
+<p:sld xmlns:a="http://schemas.openxmlformats.org/drawingml/2006/main" xmlns:r="http://schemas.openxmlformats.org/officeDocument/2006/relationships" xmlns:p="http://schemas.openxmlformats.org/presentationml/2006/main">
+  <p:cSld name="Slide 12">
+    <p:spTree>
+      <p:nvGrpSpPr>
+        <p:cNvPr id="1" name=""/>
+        <p:cNvGrpSpPr/>
+        <p:nvPr/>
+      </p:nvGrpSpPr>
+      <p:grpSpPr>
+        <a:xfrm>
+          <a:off x="0" y="0"/>
+          <a:ext cx="0" cy="0"/>
+          <a:chOff x="0" y="0"/>
+          <a:chExt cx="0" cy="0"/>
+        </a:xfrm>
+      </p:grpSpPr>
+      <p:sp>
+        <p:nvSpPr>
+          <p:cNvPr id="2" name="Kicker"/>
+          <p:cNvSpPr/>
+          <p:nvPr/>
+        </p:nvSpPr>
+        <p:spPr>
+          <a:xfrm>
+            <a:off x="548640" y="411480"/>
+            <a:ext cx="1714500" cy="310896"/>
+          </a:xfrm>
+          <a:prstGeom prst="roundRect">
+            <a:avLst>
+              <a:gd name="adj" fmla="val 50000"/>
+            </a:avLst>
+          </a:prstGeom>
+          <a:solidFill>
+            <a:srgbClr val="2F6F9F"/>
+          </a:solidFill>
+          <a:ln/>
+        </p:spPr>
+      </p:sp>
+      <p:sp>
+        <p:nvSpPr>
+          <p:cNvPr id="3" name="Text 1"/>
+          <p:cNvSpPr txBox="1"/>
+          <p:nvPr/>
+        </p:nvSpPr>
+        <p:spPr>
+          <a:xfrm>
+            <a:off x="548640" y="411480"/>
+            <a:ext cx="1714500" cy="310896"/>
+          </a:xfrm>
+          <a:prstGeom prst="rect">
+            <a:avLst/>
+          </a:prstGeom>
+          <a:noFill/>
+          <a:ln/>
+        </p:spPr>
+        <p:txBody>
+          <a:bodyPr wrap="square" lIns="0" tIns="0" rIns="0" bIns="0" rtlCol="0" anchor="ctr"/>
+          <a:lstStyle/>
+          <a:p>
+            <a:pPr algn="ctr" indent="0" marL="0">
+              <a:buNone/>
+            </a:pPr>
+            <a:r>
+              <a:rPr lang="en-US" sz="1050" b="1" spc="150" kern="0" dirty="0">
+                <a:solidFill>
+                  <a:srgbClr val="FFFFFF"/>
+                </a:solidFill>
+              </a:rPr>
+              <a:t>TRY IT YOURSELF</a:t>
+            </a:r>
+            <a:endParaRPr lang="en-US" sz="1050" dirty="0"/>
+          </a:p>
+        </p:txBody>
+      </p:sp>
+      <p:sp>
+        <p:nvSpPr>
+          <p:cNvPr id="4" name="Text 1"/>
+          <p:cNvSpPr/>
+          <p:nvPr>
+            <p:ph idx="101" type="title" hasCustomPrompt="1"/>
+          </p:nvPr>
+        </p:nvSpPr>
+        <p:spPr>
+          <a:xfrm>
+            <a:off x="548640" y="868680"/>
+            <a:ext cx="11094415" cy="777240"/>
+          </a:xfrm>
+          <a:prstGeom prst="rect">
+            <a:avLst/>
+          </a:prstGeom>
+          <a:noFill/>
+          <a:ln/>
+        </p:spPr>
+        <p:txBody>
+          <a:bodyPr wrap="square" lIns="0" tIns="0" rIns="0" bIns="0" rtlCol="0" anchor="t"/>
+          <a:lstStyle/>
+          <a:p>
+            <a:pPr algn="l" indent="0" marL="0">
+              <a:buNone/>
+            </a:pPr>
+            <a:r>
+              <a:rPr lang="en-US" sz="3200" b="1" dirty="0">
+                <a:solidFill>
+                  <a:srgbClr val="14273E"/>
+                </a:solidFill>
+                <a:latin typeface="Cambria" pitchFamily="34" charset="0"/>
+                <a:ea typeface="Cambria" pitchFamily="34" charset="-122"/>
+                <a:cs typeface="Cambria" pitchFamily="34" charset="-120"/>
+              </a:rPr>
+              <a:t>Before you move on</a:t>
+            </a:r>
+            <a:endParaRPr lang="en-US" sz="3200" dirty="0"/>
+          </a:p>
+        </p:txBody>
+      </p:sp>
+      <p:sp>
+        <p:nvSpPr>
+          <p:cNvPr id="5" name="Shape 3"/>
+          <p:cNvSpPr/>
+          <p:nvPr/>
+        </p:nvSpPr>
+        <p:spPr>
+          <a:xfrm>
+            <a:off x="548640" y="2011680"/>
+            <a:ext cx="457200" cy="457200"/>
+          </a:xfrm>
+          <a:prstGeom prst="ellipse">
+            <a:avLst/>
+          </a:prstGeom>
+          <a:solidFill>
+            <a:srgbClr val="2F6F9F"/>
+          </a:solidFill>
+          <a:ln/>
+        </p:spPr>
+      </p:sp>
+      <p:sp>
+        <p:nvSpPr>
+          <p:cNvPr id="6" name="Text 4"/>
+          <p:cNvSpPr txBox="1"/>
+          <p:nvPr/>
+        </p:nvSpPr>
+        <p:spPr>
+          <a:xfrm>
+            <a:off x="548640" y="2011680"/>
+            <a:ext cx="457200" cy="457200"/>
+          </a:xfrm>
+          <a:prstGeom prst="rect">
+            <a:avLst/>
+          </a:prstGeom>
+          <a:noFill/>
+          <a:ln/>
+        </p:spPr>
+        <p:txBody>
+          <a:bodyPr wrap="square" lIns="0" tIns="0" rIns="0" bIns="0" rtlCol="0" anchor="ctr"/>
+          <a:lstStyle/>
+          <a:p>
+            <a:pPr algn="ctr" indent="0" marL="0">
+              <a:buNone/>
+            </a:pPr>
+            <a:r>
+              <a:rPr lang="en-US" sz="1400" b="1" dirty="0">
+                <a:solidFill>
+                  <a:srgbClr val="FFFFFF"/>
+                </a:solidFill>
+              </a:rPr>
+              <a:t>1</a:t>
+            </a:r>
+            <a:endParaRPr lang="en-US" sz="1400" dirty="0"/>
+          </a:p>
+        </p:txBody>
+      </p:sp>
+      <p:sp>
+        <p:nvSpPr>
+          <p:cNvPr id="7" name="Text 5"/>
+          <p:cNvSpPr txBox="1"/>
+          <p:nvPr/>
+        </p:nvSpPr>
+        <p:spPr>
+          <a:xfrm>
+            <a:off x="1234440" y="1828800"/>
+            <a:ext cx="6035040" cy="822960"/>
+          </a:xfrm>
+          <a:prstGeom prst="rect">
+            <a:avLst/>
+          </a:prstGeom>
+          <a:noFill/>
+          <a:ln/>
+        </p:spPr>
+        <p:txBody>
+          <a:bodyPr wrap="square" lIns="0" tIns="0" rIns="0" bIns="0" rtlCol="0" anchor="ctr"/>
+          <a:lstStyle/>
+          <a:p>
+            <a:pPr indent="0" marL="0">
+              <a:buNone/>
+            </a:pPr>
+            <a:r>
+              <a:rPr lang="en-US" sz="1600" dirty="0">
+                <a:solidFill>
+                  <a:srgbClr val="1F2933"/>
+                </a:solidFill>
+              </a:rPr>
+              <a:t>Run every example; add a bonus dot to the hook.</a:t>
+            </a:r>
+            <a:endParaRPr lang="en-US" sz="1600" dirty="0"/>
+          </a:p>
+        </p:txBody>
+      </p:sp>
+      <p:sp>
+        <p:nvSpPr>
+          <p:cNvPr id="8" name="Shape 6"/>
+          <p:cNvSpPr/>
+          <p:nvPr/>
+        </p:nvSpPr>
+        <p:spPr>
+          <a:xfrm>
+            <a:off x="548640" y="2926080"/>
+            <a:ext cx="457200" cy="457200"/>
+          </a:xfrm>
+          <a:prstGeom prst="ellipse">
+            <a:avLst/>
+          </a:prstGeom>
+          <a:solidFill>
+            <a:srgbClr val="2F6F9F"/>
+          </a:solidFill>
+          <a:ln/>
+        </p:spPr>
+      </p:sp>
+      <p:sp>
+        <p:nvSpPr>
+          <p:cNvPr id="9" name="Text 7"/>
+          <p:cNvSpPr txBox="1"/>
+          <p:nvPr/>
+        </p:nvSpPr>
+        <p:spPr>
+          <a:xfrm>
+            <a:off x="548640" y="2926080"/>
+            <a:ext cx="457200" cy="457200"/>
+          </a:xfrm>
+          <a:prstGeom prst="rect">
+            <a:avLst/>
+          </a:prstGeom>
+          <a:noFill/>
+          <a:ln/>
+        </p:spPr>
+        <p:txBody>
+          <a:bodyPr wrap="square" lIns="0" tIns="0" rIns="0" bIns="0" rtlCol="0" anchor="ctr"/>
+          <a:lstStyle/>
+          <a:p>
+            <a:pPr algn="ctr" indent="0" marL="0">
+              <a:buNone/>
+            </a:pPr>
+            <a:r>
+              <a:rPr lang="en-US" sz="1400" b="1" dirty="0">
+                <a:solidFill>
+                  <a:srgbClr val="FFFFFF"/>
+                </a:solidFill>
+              </a:rPr>
+              <a:t>2</a:t>
+            </a:r>
+            <a:endParaRPr lang="en-US" sz="1400" dirty="0"/>
+          </a:p>
+        </p:txBody>
+      </p:sp>
+      <p:sp>
+        <p:nvSpPr>
+          <p:cNvPr id="10" name="Text 8"/>
+          <p:cNvSpPr txBox="1"/>
+          <p:nvPr/>
+        </p:nvSpPr>
+        <p:spPr>
+          <a:xfrm>
+            <a:off x="1234440" y="2743200"/>
+            <a:ext cx="6035040" cy="822960"/>
+          </a:xfrm>
+          <a:prstGeom prst="rect">
+            <a:avLst/>
+          </a:prstGeom>
+          <a:noFill/>
+          <a:ln/>
+        </p:spPr>
+        <p:txBody>
+          <a:bodyPr wrap="square" lIns="0" tIns="0" rIns="0" bIns="0" rtlCol="0" anchor="ctr"/>
+          <a:lstStyle/>
+          <a:p>
+            <a:pPr indent="0" marL="0">
+              <a:buNone/>
+            </a:pPr>
+            <a:r>
+              <a:rPr lang="en-US" sz="1600" dirty="0">
+                <a:solidFill>
+                  <a:srgbClr val="1F2933"/>
+                </a:solidFill>
+              </a:rPr>
+              <a:t>Exercise 1: a unit converter, with a binding.</a:t>
+            </a:r>
+            <a:endParaRPr lang="en-US" sz="1600" dirty="0"/>
+          </a:p>
+        </p:txBody>
+      </p:sp>
+      <p:sp>
+        <p:nvSpPr>
+          <p:cNvPr id="11" name="Shape 9"/>
+          <p:cNvSpPr/>
+          <p:nvPr/>
+        </p:nvSpPr>
+        <p:spPr>
+          <a:xfrm>
+            <a:off x="548640" y="3840480"/>
+            <a:ext cx="457200" cy="457200"/>
+          </a:xfrm>
+          <a:prstGeom prst="ellipse">
+            <a:avLst/>
+          </a:prstGeom>
+          <a:solidFill>
+            <a:srgbClr val="2F6F9F"/>
+          </a:solidFill>
+          <a:ln/>
+        </p:spPr>
+      </p:sp>
+      <p:sp>
+        <p:nvSpPr>
+          <p:cNvPr id="12" name="Text 10"/>
+          <p:cNvSpPr txBox="1"/>
+          <p:nvPr/>
+        </p:nvSpPr>
+        <p:spPr>
+          <a:xfrm>
+            <a:off x="548640" y="3840480"/>
+            <a:ext cx="457200" cy="457200"/>
+          </a:xfrm>
+          <a:prstGeom prst="rect">
+            <a:avLst/>
+          </a:prstGeom>
+          <a:noFill/>
+          <a:ln/>
+        </p:spPr>
+        <p:txBody>
+          <a:bodyPr wrap="square" lIns="0" tIns="0" rIns="0" bIns="0" rtlCol="0" anchor="ctr"/>
+          <a:lstStyle/>
+          <a:p>
+            <a:pPr algn="ctr" indent="0" marL="0">
+              <a:buNone/>
+            </a:pPr>
+            <a:r>
+              <a:rPr lang="en-US" sz="1400" b="1" dirty="0">
+                <a:solidFill>
+                  <a:srgbClr val="FFFFFF"/>
+                </a:solidFill>
+              </a:rPr>
+              <a:t>3</a:t>
+            </a:r>
+            <a:endParaRPr lang="en-US" sz="1400" dirty="0"/>
+          </a:p>
+        </p:txBody>
+      </p:sp>
+      <p:sp>
+        <p:nvSpPr>
+          <p:cNvPr id="13" name="Text 11"/>
+          <p:cNvSpPr txBox="1"/>
+          <p:nvPr/>
+        </p:nvSpPr>
+        <p:spPr>
+          <a:xfrm>
+            <a:off x="1234440" y="3657600"/>
+            <a:ext cx="6035040" cy="822960"/>
+          </a:xfrm>
+          <a:prstGeom prst="rect">
+            <a:avLst/>
+          </a:prstGeom>
+          <a:noFill/>
+          <a:ln/>
+        </p:spPr>
+        <p:txBody>
+          <a:bodyPr wrap="square" lIns="0" tIns="0" rIns="0" bIns="0" rtlCol="0" anchor="ctr"/>
+          <a:lstStyle/>
+          <a:p>
+            <a:pPr indent="0" marL="0">
+              <a:buNone/>
+            </a:pPr>
+            <a:r>
+              <a:rPr lang="en-US" sz="1600" dirty="0">
+                <a:solidFill>
+                  <a:srgbClr val="1F2933"/>
+                </a:solidFill>
+              </a:rPr>
+              <a:t>Exercise 2: a calculator model that passes 16 tests.</a:t>
+            </a:r>
+            <a:endParaRPr lang="en-US" sz="1600" dirty="0"/>
+          </a:p>
+        </p:txBody>
+      </p:sp>
+      <p:sp>
+        <p:nvSpPr>
+          <p:cNvPr id="14" name="Shape 12"/>
+          <p:cNvSpPr/>
+          <p:nvPr/>
+        </p:nvSpPr>
+        <p:spPr>
+          <a:xfrm>
+            <a:off x="548640" y="4754880"/>
+            <a:ext cx="457200" cy="457200"/>
+          </a:xfrm>
+          <a:prstGeom prst="ellipse">
+            <a:avLst/>
+          </a:prstGeom>
+          <a:solidFill>
+            <a:srgbClr val="2F6F9F"/>
+          </a:solidFill>
+          <a:ln/>
+        </p:spPr>
+      </p:sp>
+      <p:sp>
+        <p:nvSpPr>
+          <p:cNvPr id="15" name="Text 13"/>
+          <p:cNvSpPr txBox="1"/>
+          <p:nvPr/>
+        </p:nvSpPr>
+        <p:spPr>
+          <a:xfrm>
+            <a:off x="548640" y="4754880"/>
+            <a:ext cx="457200" cy="457200"/>
+          </a:xfrm>
+          <a:prstGeom prst="rect">
+            <a:avLst/>
+          </a:prstGeom>
+          <a:noFill/>
+          <a:ln/>
+        </p:spPr>
+        <p:txBody>
+          <a:bodyPr wrap="square" lIns="0" tIns="0" rIns="0" bIns="0" rtlCol="0" anchor="ctr"/>
+          <a:lstStyle/>
+          <a:p>
+            <a:pPr algn="ctr" indent="0" marL="0">
+              <a:buNone/>
+            </a:pPr>
+            <a:r>
+              <a:rPr lang="en-US" sz="1400" b="1" dirty="0">
+                <a:solidFill>
+                  <a:srgbClr val="FFFFFF"/>
+                </a:solidFill>
+              </a:rPr>
+              <a:t>4</a:t>
+            </a:r>
+            <a:endParaRPr lang="en-US" sz="1400" dirty="0"/>
+          </a:p>
+        </p:txBody>
+      </p:sp>
+      <p:sp>
+        <p:nvSpPr>
+          <p:cNvPr id="16" name="Text 14"/>
+          <p:cNvSpPr txBox="1"/>
+          <p:nvPr/>
+        </p:nvSpPr>
+        <p:spPr>
+          <a:xfrm>
+            <a:off x="1234440" y="4572000"/>
+            <a:ext cx="6035040" cy="822960"/>
+          </a:xfrm>
+          <a:prstGeom prst="rect">
+            <a:avLst/>
+          </a:prstGeom>
+          <a:noFill/>
+          <a:ln/>
+        </p:spPr>
+        <p:txBody>
+          <a:bodyPr wrap="square" lIns="0" tIns="0" rIns="0" bIns="0" rtlCol="0" anchor="ctr"/>
+          <a:lstStyle/>
+          <a:p>
+            <a:pPr indent="0" marL="0">
+              <a:buNone/>
+            </a:pPr>
+            <a:r>
+              <a:rPr lang="en-US" sz="1600" dirty="0">
+                <a:solidFill>
+                  <a:srgbClr val="1F2933"/>
+                </a:solidFill>
+              </a:rPr>
+              <a:t>Build the project in your track.</a:t>
+            </a:r>
+            <a:endParaRPr lang="en-US" sz="1600" dirty="0"/>
+          </a:p>
+        </p:txBody>
+      </p:sp>
+      <p:sp>
+        <p:nvSpPr>
+          <p:cNvPr id="17" name="Project card"/>
+          <p:cNvSpPr/>
+          <p:nvPr/>
+        </p:nvSpPr>
+        <p:spPr>
+          <a:xfrm>
+            <a:off x="7589520" y="1828800"/>
+            <a:ext cx="4053535" cy="4297680"/>
+          </a:xfrm>
+          <a:prstGeom prst="roundRect">
+            <a:avLst>
+              <a:gd name="adj" fmla="val 2707"/>
+            </a:avLst>
+          </a:prstGeom>
+          <a:solidFill>
+            <a:srgbClr val="152536"/>
+          </a:solidFill>
+          <a:ln/>
+        </p:spPr>
+      </p:sp>
+      <p:sp>
+        <p:nvSpPr>
+          <p:cNvPr id="18" name="Text 16"/>
+          <p:cNvSpPr txBox="1"/>
+          <p:nvPr/>
+        </p:nvSpPr>
+        <p:spPr>
+          <a:xfrm>
+            <a:off x="7909560" y="2103120"/>
+            <a:ext cx="3413455" cy="320040"/>
+          </a:xfrm>
+          <a:prstGeom prst="rect">
+            <a:avLst/>
+          </a:prstGeom>
+          <a:noFill/>
+          <a:ln/>
+        </p:spPr>
+        <p:txBody>
+          <a:bodyPr wrap="square" lIns="0" tIns="0" rIns="0" bIns="0" rtlCol="0" anchor="ctr"/>
+          <a:lstStyle/>
+          <a:p>
+            <a:pPr indent="0" marL="0">
+              <a:buNone/>
+            </a:pPr>
+            <a:r>
+              <a:rPr lang="en-US" sz="1100" b="1" spc="200" kern="0" dirty="0">
+                <a:solidFill>
+                  <a:srgbClr val="F89820"/>
+                </a:solidFill>
+              </a:rPr>
+              <a:t>MODULE PROJECT</a:t>
+            </a:r>
+            <a:endParaRPr lang="en-US" sz="1100" dirty="0"/>
+          </a:p>
+        </p:txBody>
+      </p:sp>
+      <p:sp>
+        <p:nvSpPr>
+          <p:cNvPr id="19" name="Text 17"/>
+          <p:cNvSpPr txBox="1"/>
+          <p:nvPr/>
+        </p:nvSpPr>
+        <p:spPr>
+          <a:xfrm>
+            <a:off x="7909560" y="2468880"/>
+            <a:ext cx="3413455" cy="1005840"/>
+          </a:xfrm>
+          <a:prstGeom prst="rect">
+            <a:avLst/>
+          </a:prstGeom>
+          <a:noFill/>
+          <a:ln/>
+        </p:spPr>
+        <p:txBody>
+          <a:bodyPr wrap="square" lIns="0" tIns="0" rIns="0" bIns="0" rtlCol="0" anchor="t"/>
+          <a:lstStyle/>
+          <a:p>
+            <a:pPr indent="0" marL="0">
+              <a:buNone/>
+            </a:pPr>
+            <a:r>
+              <a:rPr lang="en-US" sz="2400" b="1" dirty="0">
+                <a:solidFill>
+                  <a:srgbClr val="FFFFFF"/>
+                </a:solidFill>
+                <a:latin typeface="Cambria" pitchFamily="34" charset="0"/>
+                <a:ea typeface="Cambria" pitchFamily="34" charset="-122"/>
+                <a:cs typeface="Cambria" pitchFamily="34" charset="-120"/>
+              </a:rPr>
+              <a:t>A Real Windowed Application</a:t>
+            </a:r>
+            <a:endParaRPr lang="en-US" sz="2400" dirty="0"/>
+          </a:p>
+        </p:txBody>
+      </p:sp>
+      <p:sp>
+        <p:nvSpPr>
+          <p:cNvPr id="20" name="Text 18"/>
+          <p:cNvSpPr txBox="1"/>
+          <p:nvPr/>
+        </p:nvSpPr>
+        <p:spPr>
+          <a:xfrm>
+            <a:off x="7909560" y="3566160"/>
+            <a:ext cx="3413455" cy="1920240"/>
+          </a:xfrm>
+          <a:prstGeom prst="rect">
+            <a:avLst/>
+          </a:prstGeom>
+          <a:noFill/>
+          <a:ln/>
+        </p:spPr>
+        <p:txBody>
+          <a:bodyPr wrap="square" lIns="0" tIns="0" rIns="0" bIns="0" rtlCol="0" anchor="t"/>
+          <a:lstStyle/>
+          <a:p>
+            <a:pPr indent="0" marL="0">
+              <a:buNone/>
+            </a:pPr>
+            <a:r>
+              <a:rPr lang="en-US" sz="1450" dirty="0">
+                <a:solidFill>
+                  <a:srgbClr val="DCE4EE"/>
+                </a:solidFill>
+              </a:rPr>
+              <a:t>Track A: a study planner with a TableView. Track B: a resistor colour code calculator with a drawn resistor. Track C: a vitals dashboard with a LineChart.</a:t>
+            </a:r>
+            <a:endParaRPr lang="en-US" sz="1450" dirty="0"/>
+          </a:p>
+        </p:txBody>
+      </p:sp>
+      <p:sp>
+        <p:nvSpPr>
+          <p:cNvPr id="21" name="Text 19"/>
+          <p:cNvSpPr txBox="1"/>
+          <p:nvPr/>
+        </p:nvSpPr>
+        <p:spPr>
+          <a:xfrm>
+            <a:off x="7909560" y="5577840"/>
+            <a:ext cx="3413455" cy="365760"/>
+          </a:xfrm>
+          <a:prstGeom prst="rect">
+            <a:avLst/>
+          </a:prstGeom>
+          <a:noFill/>
+          <a:ln/>
+        </p:spPr>
+        <p:txBody>
+          <a:bodyPr wrap="square" lIns="0" tIns="0" rIns="0" bIns="0" rtlCol="0" anchor="ctr"/>
+          <a:lstStyle/>
+          <a:p>
+            <a:pPr indent="0" marL="0">
+              <a:buNone/>
+            </a:pPr>
+            <a:r>
+              <a:rPr lang="en-US" sz="1250" b="1" dirty="0">
+                <a:solidFill>
+                  <a:srgbClr val="F89820"/>
+                </a:solidFill>
+              </a:rPr>
+              <a:t>Next: Module 19, Capstone 2</a:t>
+            </a:r>
+            <a:endParaRPr lang="en-US" sz="1250" dirty="0"/>
+          </a:p>
+        </p:txBody>
+      </p:sp>
+      <p:sp>
+        <p:nvSpPr>
+          <p:cNvPr id="25" name="Slide Number Placeholder 0"/>
+          <p:cNvSpPr>
+            <a:spLocks noGrp="1"/>
+          </p:cNvSpPr>
+          <p:nvPr>
+            <p:ph type="sldNum" sz="quarter" idx="4294967295"/>
+          </p:nvPr>
+        </p:nvSpPr>
+        <p:spPr>
+          <a:xfrm>
+            <a:off x="11094415" y="6400800"/>
+            <a:ext cx="548640" cy="274320"/>
+          </a:xfrm>
+          <a:prstGeom prst="rect">
+            <a:avLst/>
+          </a:prstGeom>
+          <a:extLst>
+            <a:ext uri="{C572A759-6A51-4108-AA02-DFA0A04FC94B}">
+              <ma14:wrappingTextBoxFlag xmlns:ma14="http://schemas.microsoft.com/office/mac/drawingml/2011/main" val="0"/>
+            </a:ext>
+          </a:extLst>
+        </p:spPr>
+        <p:txBody>
+          <a:bodyPr/>
+          <a:lstStyle>
+            <a:lvl1pPr>
+              <a:defRPr sz="900">
+                <a:solidFill>
+                  <a:srgbClr val="8A97A8"/>
+                </a:solidFill>
+              </a:defRPr>
+            </a:lvl1pPr>
+          </a:lstStyle>
+          <a:p>
+            <a:pPr algn="r"/>
+            <a:fld id="{F7021451-1387-4CA6-816F-3879F97B5CBC}" type="slidenum">
+              <a:rPr b="0" lang="en-US"/>
+              <a:t>12</a:t>
             </a:fld>
             <a:endParaRPr lang="en-US"/>
           </a:p>

</xml_diff>